<commit_message>
docs: adiciona gráficos unificados e scripts geradores para ST e MP no benchmark V5
</commit_message>
<xml_diff>
--- a/Apresentação - Projeto 02.pptx
+++ b/Apresentação - Projeto 02.pptx
@@ -9,17 +9,18 @@
     <p:sldId id="257" r:id="rId3"/>
     <p:sldId id="262" r:id="rId4"/>
     <p:sldId id="269" r:id="rId5"/>
-    <p:sldId id="263" r:id="rId6"/>
-    <p:sldId id="275" r:id="rId7"/>
-    <p:sldId id="274" r:id="rId8"/>
-    <p:sldId id="265" r:id="rId9"/>
-    <p:sldId id="270" r:id="rId10"/>
-    <p:sldId id="272" r:id="rId11"/>
-    <p:sldId id="271" r:id="rId12"/>
-    <p:sldId id="273" r:id="rId13"/>
-    <p:sldId id="266" r:id="rId14"/>
-    <p:sldId id="267" r:id="rId15"/>
-    <p:sldId id="268" r:id="rId16"/>
+    <p:sldId id="276" r:id="rId6"/>
+    <p:sldId id="263" r:id="rId7"/>
+    <p:sldId id="275" r:id="rId8"/>
+    <p:sldId id="274" r:id="rId9"/>
+    <p:sldId id="265" r:id="rId10"/>
+    <p:sldId id="270" r:id="rId11"/>
+    <p:sldId id="272" r:id="rId12"/>
+    <p:sldId id="271" r:id="rId13"/>
+    <p:sldId id="273" r:id="rId14"/>
+    <p:sldId id="266" r:id="rId15"/>
+    <p:sldId id="267" r:id="rId16"/>
+    <p:sldId id="268" r:id="rId17"/>
   </p:sldIdLst>
   <p:sldSz cx="12192000" cy="6858000"/>
   <p:notesSz cx="6858000" cy="9144000"/>
@@ -273,7 +274,7 @@
           <a:p>
             <a:fld id="{E3706E84-BC9D-4EE9-9198-D52ADEF0FD9C}" type="datetimeFigureOut">
               <a:rPr lang="pt-BR" smtClean="0"/>
-              <a:t>06/04/2026</a:t>
+              <a:t>07/04/2026</a:t>
             </a:fld>
             <a:endParaRPr lang="pt-BR"/>
           </a:p>
@@ -471,7 +472,7 @@
           <a:p>
             <a:fld id="{E3706E84-BC9D-4EE9-9198-D52ADEF0FD9C}" type="datetimeFigureOut">
               <a:rPr lang="pt-BR" smtClean="0"/>
-              <a:t>06/04/2026</a:t>
+              <a:t>07/04/2026</a:t>
             </a:fld>
             <a:endParaRPr lang="pt-BR"/>
           </a:p>
@@ -679,7 +680,7 @@
           <a:p>
             <a:fld id="{E3706E84-BC9D-4EE9-9198-D52ADEF0FD9C}" type="datetimeFigureOut">
               <a:rPr lang="pt-BR" smtClean="0"/>
-              <a:t>06/04/2026</a:t>
+              <a:t>07/04/2026</a:t>
             </a:fld>
             <a:endParaRPr lang="pt-BR"/>
           </a:p>
@@ -877,7 +878,7 @@
           <a:p>
             <a:fld id="{E3706E84-BC9D-4EE9-9198-D52ADEF0FD9C}" type="datetimeFigureOut">
               <a:rPr lang="pt-BR" smtClean="0"/>
-              <a:t>06/04/2026</a:t>
+              <a:t>07/04/2026</a:t>
             </a:fld>
             <a:endParaRPr lang="pt-BR"/>
           </a:p>
@@ -1152,7 +1153,7 @@
           <a:p>
             <a:fld id="{E3706E84-BC9D-4EE9-9198-D52ADEF0FD9C}" type="datetimeFigureOut">
               <a:rPr lang="pt-BR" smtClean="0"/>
-              <a:t>06/04/2026</a:t>
+              <a:t>07/04/2026</a:t>
             </a:fld>
             <a:endParaRPr lang="pt-BR"/>
           </a:p>
@@ -1417,7 +1418,7 @@
           <a:p>
             <a:fld id="{E3706E84-BC9D-4EE9-9198-D52ADEF0FD9C}" type="datetimeFigureOut">
               <a:rPr lang="pt-BR" smtClean="0"/>
-              <a:t>06/04/2026</a:t>
+              <a:t>07/04/2026</a:t>
             </a:fld>
             <a:endParaRPr lang="pt-BR"/>
           </a:p>
@@ -1829,7 +1830,7 @@
           <a:p>
             <a:fld id="{E3706E84-BC9D-4EE9-9198-D52ADEF0FD9C}" type="datetimeFigureOut">
               <a:rPr lang="pt-BR" smtClean="0"/>
-              <a:t>06/04/2026</a:t>
+              <a:t>07/04/2026</a:t>
             </a:fld>
             <a:endParaRPr lang="pt-BR"/>
           </a:p>
@@ -1970,7 +1971,7 @@
           <a:p>
             <a:fld id="{E3706E84-BC9D-4EE9-9198-D52ADEF0FD9C}" type="datetimeFigureOut">
               <a:rPr lang="pt-BR" smtClean="0"/>
-              <a:t>06/04/2026</a:t>
+              <a:t>07/04/2026</a:t>
             </a:fld>
             <a:endParaRPr lang="pt-BR"/>
           </a:p>
@@ -2083,7 +2084,7 @@
           <a:p>
             <a:fld id="{E3706E84-BC9D-4EE9-9198-D52ADEF0FD9C}" type="datetimeFigureOut">
               <a:rPr lang="pt-BR" smtClean="0"/>
-              <a:t>06/04/2026</a:t>
+              <a:t>07/04/2026</a:t>
             </a:fld>
             <a:endParaRPr lang="pt-BR"/>
           </a:p>
@@ -2394,7 +2395,7 @@
           <a:p>
             <a:fld id="{E3706E84-BC9D-4EE9-9198-D52ADEF0FD9C}" type="datetimeFigureOut">
               <a:rPr lang="pt-BR" smtClean="0"/>
-              <a:t>06/04/2026</a:t>
+              <a:t>07/04/2026</a:t>
             </a:fld>
             <a:endParaRPr lang="pt-BR"/>
           </a:p>
@@ -2682,7 +2683,7 @@
           <a:p>
             <a:fld id="{E3706E84-BC9D-4EE9-9198-D52ADEF0FD9C}" type="datetimeFigureOut">
               <a:rPr lang="pt-BR" smtClean="0"/>
-              <a:t>06/04/2026</a:t>
+              <a:t>07/04/2026</a:t>
             </a:fld>
             <a:endParaRPr lang="pt-BR"/>
           </a:p>
@@ -2923,7 +2924,7 @@
           <a:p>
             <a:fld id="{E3706E84-BC9D-4EE9-9198-D52ADEF0FD9C}" type="datetimeFigureOut">
               <a:rPr lang="pt-BR" smtClean="0"/>
-              <a:t>06/04/2026</a:t>
+              <a:t>07/04/2026</a:t>
             </a:fld>
             <a:endParaRPr lang="pt-BR"/>
           </a:p>
@@ -3905,6 +3906,540 @@
         <p:cNvPr id="1" name="">
           <a:extLst>
             <a:ext uri="{FF2B5EF4-FFF2-40B4-BE49-F238E27FC236}">
+              <a16:creationId xmlns:a16="http://schemas.microsoft.com/office/drawing/2014/main" id="{E164B671-FC38-2847-0962-11B4314CAE5D}"/>
+            </a:ext>
+          </a:extLst>
+        </p:cNvPr>
+        <p:cNvGrpSpPr/>
+        <p:nvPr/>
+      </p:nvGrpSpPr>
+      <p:grpSpPr>
+        <a:xfrm>
+          <a:off x="0" y="0"/>
+          <a:ext cx="0" cy="0"/>
+          <a:chOff x="0" y="0"/>
+          <a:chExt cx="0" cy="0"/>
+        </a:xfrm>
+      </p:grpSpPr>
+      <p:pic>
+        <p:nvPicPr>
+          <p:cNvPr id="5" name="Imagem 4">
+            <a:extLst>
+              <a:ext uri="{FF2B5EF4-FFF2-40B4-BE49-F238E27FC236}">
+                <a16:creationId xmlns:a16="http://schemas.microsoft.com/office/drawing/2014/main" id="{14A210E9-96BE-6AEF-888F-BC27D770B970}"/>
+              </a:ext>
+            </a:extLst>
+          </p:cNvPr>
+          <p:cNvPicPr>
+            <a:picLocks noChangeAspect="1"/>
+          </p:cNvPicPr>
+          <p:nvPr/>
+        </p:nvPicPr>
+        <p:blipFill>
+          <a:blip r:embed="rId2"/>
+          <a:stretch>
+            <a:fillRect/>
+          </a:stretch>
+        </p:blipFill>
+        <p:spPr>
+          <a:xfrm>
+            <a:off x="0" y="0"/>
+            <a:ext cx="12192000" cy="1398060"/>
+          </a:xfrm>
+          <a:prstGeom prst="rect">
+            <a:avLst/>
+          </a:prstGeom>
+        </p:spPr>
+      </p:pic>
+      <p:grpSp>
+        <p:nvGrpSpPr>
+          <p:cNvPr id="10" name="Agrupar 9">
+            <a:extLst>
+              <a:ext uri="{FF2B5EF4-FFF2-40B4-BE49-F238E27FC236}">
+                <a16:creationId xmlns:a16="http://schemas.microsoft.com/office/drawing/2014/main" id="{6B17D0A5-FA6E-7612-F4EA-B08B6E431FA9}"/>
+              </a:ext>
+            </a:extLst>
+          </p:cNvPr>
+          <p:cNvGrpSpPr/>
+          <p:nvPr/>
+        </p:nvGrpSpPr>
+        <p:grpSpPr>
+          <a:xfrm>
+            <a:off x="4739781" y="3585812"/>
+            <a:ext cx="7452219" cy="3272188"/>
+            <a:chOff x="4739781" y="3585812"/>
+            <a:chExt cx="7452219" cy="3272188"/>
+          </a:xfrm>
+        </p:grpSpPr>
+        <p:pic>
+          <p:nvPicPr>
+            <p:cNvPr id="7" name="Imagem 6">
+              <a:extLst>
+                <a:ext uri="{FF2B5EF4-FFF2-40B4-BE49-F238E27FC236}">
+                  <a16:creationId xmlns:a16="http://schemas.microsoft.com/office/drawing/2014/main" id="{C0A576E9-D595-470C-A40E-2194D8494497}"/>
+                </a:ext>
+              </a:extLst>
+            </p:cNvPr>
+            <p:cNvPicPr>
+              <a:picLocks noChangeAspect="1"/>
+            </p:cNvPicPr>
+            <p:nvPr/>
+          </p:nvPicPr>
+          <p:blipFill>
+            <a:blip r:embed="rId3"/>
+            <a:stretch>
+              <a:fillRect/>
+            </a:stretch>
+          </p:blipFill>
+          <p:spPr>
+            <a:xfrm>
+              <a:off x="5492514" y="4013377"/>
+              <a:ext cx="6699486" cy="2844623"/>
+            </a:xfrm>
+            <a:prstGeom prst="rect">
+              <a:avLst/>
+            </a:prstGeom>
+            <a:effectLst>
+              <a:outerShdw blurRad="50800" dist="50800" dir="5400000" algn="ctr" rotWithShape="0">
+                <a:srgbClr val="000000"/>
+              </a:outerShdw>
+            </a:effectLst>
+          </p:spPr>
+        </p:pic>
+        <p:sp>
+          <p:nvSpPr>
+            <p:cNvPr id="8" name="Retângulo 7">
+              <a:extLst>
+                <a:ext uri="{FF2B5EF4-FFF2-40B4-BE49-F238E27FC236}">
+                  <a16:creationId xmlns:a16="http://schemas.microsoft.com/office/drawing/2014/main" id="{6330B5B5-14A9-566F-3454-C956FFC60E8C}"/>
+                </a:ext>
+              </a:extLst>
+            </p:cNvPr>
+            <p:cNvSpPr/>
+            <p:nvPr/>
+          </p:nvSpPr>
+          <p:spPr>
+            <a:xfrm>
+              <a:off x="4739781" y="4013377"/>
+              <a:ext cx="1104550" cy="2844623"/>
+            </a:xfrm>
+            <a:prstGeom prst="rect">
+              <a:avLst/>
+            </a:prstGeom>
+            <a:solidFill>
+              <a:schemeClr val="bg1"/>
+            </a:solidFill>
+            <a:ln>
+              <a:solidFill>
+                <a:schemeClr val="bg1"/>
+              </a:solidFill>
+            </a:ln>
+          </p:spPr>
+          <p:style>
+            <a:lnRef idx="2">
+              <a:schemeClr val="accent1">
+                <a:shade val="15000"/>
+              </a:schemeClr>
+            </a:lnRef>
+            <a:fillRef idx="1">
+              <a:schemeClr val="accent1"/>
+            </a:fillRef>
+            <a:effectRef idx="0">
+              <a:schemeClr val="accent1"/>
+            </a:effectRef>
+            <a:fontRef idx="minor">
+              <a:schemeClr val="lt1"/>
+            </a:fontRef>
+          </p:style>
+          <p:txBody>
+            <a:bodyPr rtlCol="0" anchor="ctr"/>
+            <a:lstStyle/>
+            <a:p>
+              <a:pPr algn="ctr"/>
+              <a:endParaRPr lang="pt-BR"/>
+            </a:p>
+          </p:txBody>
+        </p:sp>
+        <p:sp>
+          <p:nvSpPr>
+            <p:cNvPr id="9" name="Retângulo 8">
+              <a:extLst>
+                <a:ext uri="{FF2B5EF4-FFF2-40B4-BE49-F238E27FC236}">
+                  <a16:creationId xmlns:a16="http://schemas.microsoft.com/office/drawing/2014/main" id="{484C3208-5267-F20F-10D0-69E389B21B7E}"/>
+                </a:ext>
+              </a:extLst>
+            </p:cNvPr>
+            <p:cNvSpPr/>
+            <p:nvPr/>
+          </p:nvSpPr>
+          <p:spPr>
+            <a:xfrm>
+              <a:off x="5292056" y="3585812"/>
+              <a:ext cx="4453856" cy="1078467"/>
+            </a:xfrm>
+            <a:prstGeom prst="rect">
+              <a:avLst/>
+            </a:prstGeom>
+            <a:solidFill>
+              <a:schemeClr val="bg1"/>
+            </a:solidFill>
+            <a:ln>
+              <a:solidFill>
+                <a:schemeClr val="bg1"/>
+              </a:solidFill>
+            </a:ln>
+          </p:spPr>
+          <p:style>
+            <a:lnRef idx="2">
+              <a:schemeClr val="accent1">
+                <a:shade val="15000"/>
+              </a:schemeClr>
+            </a:lnRef>
+            <a:fillRef idx="1">
+              <a:schemeClr val="accent1"/>
+            </a:fillRef>
+            <a:effectRef idx="0">
+              <a:schemeClr val="accent1"/>
+            </a:effectRef>
+            <a:fontRef idx="minor">
+              <a:schemeClr val="lt1"/>
+            </a:fontRef>
+          </p:style>
+          <p:txBody>
+            <a:bodyPr rtlCol="0" anchor="ctr"/>
+            <a:lstStyle/>
+            <a:p>
+              <a:pPr algn="ctr"/>
+              <a:endParaRPr lang="pt-BR"/>
+            </a:p>
+          </p:txBody>
+        </p:sp>
+      </p:grpSp>
+      <p:sp>
+        <p:nvSpPr>
+          <p:cNvPr id="16" name="Título 1">
+            <a:extLst>
+              <a:ext uri="{FF2B5EF4-FFF2-40B4-BE49-F238E27FC236}">
+                <a16:creationId xmlns:a16="http://schemas.microsoft.com/office/drawing/2014/main" id="{3F1C265C-450B-E149-E6F1-8766C3132B27}"/>
+              </a:ext>
+            </a:extLst>
+          </p:cNvPr>
+          <p:cNvSpPr>
+            <a:spLocks noGrp="1"/>
+          </p:cNvSpPr>
+          <p:nvPr>
+            <p:ph type="title"/>
+          </p:nvPr>
+        </p:nvSpPr>
+        <p:spPr>
+          <a:xfrm>
+            <a:off x="474860" y="1162843"/>
+            <a:ext cx="10515600" cy="1325563"/>
+          </a:xfrm>
+        </p:spPr>
+        <p:txBody>
+          <a:bodyPr>
+            <a:normAutofit/>
+          </a:bodyPr>
+          <a:lstStyle/>
+          <a:p>
+            <a:r>
+              <a:rPr lang="pt-BR" sz="2800" b="1" dirty="0">
+                <a:latin typeface="+mn-lt"/>
+              </a:rPr>
+              <a:t>A Árvore BST e a Volatilidade Estrutural</a:t>
+            </a:r>
+          </a:p>
+        </p:txBody>
+      </p:sp>
+      <p:sp>
+        <p:nvSpPr>
+          <p:cNvPr id="13" name="Rectangle 1">
+            <a:extLst>
+              <a:ext uri="{FF2B5EF4-FFF2-40B4-BE49-F238E27FC236}">
+                <a16:creationId xmlns:a16="http://schemas.microsoft.com/office/drawing/2014/main" id="{379EF3F8-DAA6-B371-6726-DD0D059AD3EC}"/>
+              </a:ext>
+            </a:extLst>
+          </p:cNvPr>
+          <p:cNvSpPr>
+            <a:spLocks noGrp="1" noChangeArrowheads="1"/>
+          </p:cNvSpPr>
+          <p:nvPr>
+            <p:ph idx="1"/>
+          </p:nvPr>
+        </p:nvSpPr>
+        <p:spPr bwMode="auto">
+          <a:xfrm>
+            <a:off x="1075630" y="2382161"/>
+            <a:ext cx="10515600" cy="3262432"/>
+          </a:xfrm>
+          <a:prstGeom prst="rect">
+            <a:avLst/>
+          </a:prstGeom>
+          <a:noFill/>
+          <a:ln>
+            <a:noFill/>
+          </a:ln>
+          <a:effectLst/>
+          <a:extLst>
+            <a:ext uri="{909E8E84-426E-40DD-AFC4-6F175D3DCCD1}">
+              <a14:hiddenFill xmlns:a14="http://schemas.microsoft.com/office/drawing/2010/main">
+                <a:solidFill>
+                  <a:schemeClr val="accent1"/>
+                </a:solidFill>
+              </a14:hiddenFill>
+            </a:ext>
+            <a:ext uri="{91240B29-F687-4F45-9708-019B960494DF}">
+              <a14:hiddenLine xmlns:a14="http://schemas.microsoft.com/office/drawing/2010/main" w="9525">
+                <a:solidFill>
+                  <a:schemeClr val="tx1"/>
+                </a:solidFill>
+                <a:miter lim="800000"/>
+                <a:headEnd/>
+                <a:tailEnd/>
+              </a14:hiddenLine>
+            </a:ext>
+            <a:ext uri="{AF507438-7753-43E0-B8FC-AC1667EBCBE1}">
+              <a14:hiddenEffects xmlns:a14="http://schemas.microsoft.com/office/drawing/2010/main">
+                <a:effectLst>
+                  <a:outerShdw dist="35921" dir="2700000" algn="ctr" rotWithShape="0">
+                    <a:schemeClr val="bg2"/>
+                  </a:outerShdw>
+                </a:effectLst>
+              </a14:hiddenEffects>
+            </a:ext>
+          </a:extLst>
+        </p:spPr>
+        <p:txBody>
+          <a:bodyPr vert="horz" wrap="square" lIns="91440" tIns="45720" rIns="91440" bIns="45720" numCol="1" anchor="ctr" anchorCtr="0" compatLnSpc="1">
+            <a:prstTxWarp prst="textNoShape">
+              <a:avLst/>
+            </a:prstTxWarp>
+            <a:spAutoFit/>
+          </a:bodyPr>
+          <a:lstStyle/>
+          <a:p>
+            <a:pPr marL="0" indent="0" eaLnBrk="0" fontAlgn="base" hangingPunct="0">
+              <a:lnSpc>
+                <a:spcPct val="100000"/>
+              </a:lnSpc>
+              <a:spcBef>
+                <a:spcPct val="0"/>
+              </a:spcBef>
+              <a:spcAft>
+                <a:spcPct val="0"/>
+              </a:spcAft>
+              <a:buFontTx/>
+              <a:buChar char="•"/>
+            </a:pPr>
+            <a:r>
+              <a:rPr lang="pt-BR" altLang="pt-BR" sz="2400" b="1" dirty="0"/>
+              <a:t> Topologicamente vulnerável a entrada dos dados</a:t>
+            </a:r>
+          </a:p>
+          <a:p>
+            <a:pPr marL="0" indent="0" eaLnBrk="0" fontAlgn="base" hangingPunct="0">
+              <a:lnSpc>
+                <a:spcPct val="100000"/>
+              </a:lnSpc>
+              <a:spcBef>
+                <a:spcPct val="0"/>
+              </a:spcBef>
+              <a:spcAft>
+                <a:spcPct val="0"/>
+              </a:spcAft>
+              <a:buFontTx/>
+              <a:buChar char="•"/>
+            </a:pPr>
+            <a:endParaRPr lang="pt-BR" altLang="pt-BR" sz="2400" b="1" dirty="0"/>
+          </a:p>
+          <a:p>
+            <a:pPr marL="457200" lvl="1" indent="0" eaLnBrk="0" fontAlgn="base" hangingPunct="0">
+              <a:lnSpc>
+                <a:spcPct val="100000"/>
+              </a:lnSpc>
+              <a:spcBef>
+                <a:spcPct val="0"/>
+              </a:spcBef>
+              <a:spcAft>
+                <a:spcPct val="0"/>
+              </a:spcAft>
+              <a:buFontTx/>
+              <a:buChar char="•"/>
+            </a:pPr>
+            <a:r>
+              <a:rPr lang="pt-BR" altLang="pt-BR" sz="2000" b="1" dirty="0"/>
+              <a:t> Dados ordenados</a:t>
+            </a:r>
+          </a:p>
+          <a:p>
+            <a:pPr marL="914400" lvl="2" indent="0" eaLnBrk="0" fontAlgn="base" hangingPunct="0">
+              <a:lnSpc>
+                <a:spcPct val="100000"/>
+              </a:lnSpc>
+              <a:spcBef>
+                <a:spcPct val="0"/>
+              </a:spcBef>
+              <a:spcAft>
+                <a:spcPct val="0"/>
+              </a:spcAft>
+              <a:buFontTx/>
+              <a:buChar char="•"/>
+            </a:pPr>
+            <a:r>
+              <a:rPr lang="pt-BR" altLang="pt-BR" dirty="0"/>
+              <a:t> “Lista encadeada” - O(N)</a:t>
+            </a:r>
+          </a:p>
+          <a:p>
+            <a:pPr marL="457200" lvl="1" indent="0" eaLnBrk="0" fontAlgn="base" hangingPunct="0">
+              <a:lnSpc>
+                <a:spcPct val="100000"/>
+              </a:lnSpc>
+              <a:spcBef>
+                <a:spcPct val="0"/>
+              </a:spcBef>
+              <a:spcAft>
+                <a:spcPct val="0"/>
+              </a:spcAft>
+              <a:buFontTx/>
+              <a:buChar char="•"/>
+            </a:pPr>
+            <a:r>
+              <a:rPr lang="pt-BR" altLang="pt-BR" sz="2000" b="1" dirty="0"/>
+              <a:t> Dados aleatórios</a:t>
+            </a:r>
+          </a:p>
+          <a:p>
+            <a:pPr marL="914400" lvl="2" indent="0" eaLnBrk="0" fontAlgn="base" hangingPunct="0">
+              <a:lnSpc>
+                <a:spcPct val="100000"/>
+              </a:lnSpc>
+              <a:spcBef>
+                <a:spcPct val="0"/>
+              </a:spcBef>
+              <a:spcAft>
+                <a:spcPct val="0"/>
+              </a:spcAft>
+              <a:buFontTx/>
+              <a:buChar char="•"/>
+            </a:pPr>
+            <a:r>
+              <a:rPr lang="pt-BR" altLang="pt-BR" dirty="0"/>
+              <a:t> Árvore naturalmente balanceada</a:t>
+            </a:r>
+          </a:p>
+          <a:p>
+            <a:pPr marL="914400" lvl="2" indent="0" eaLnBrk="0" fontAlgn="base" hangingPunct="0">
+              <a:lnSpc>
+                <a:spcPct val="100000"/>
+              </a:lnSpc>
+              <a:spcBef>
+                <a:spcPct val="0"/>
+              </a:spcBef>
+              <a:spcAft>
+                <a:spcPct val="0"/>
+              </a:spcAft>
+              <a:buFontTx/>
+              <a:buChar char="•"/>
+            </a:pPr>
+            <a:r>
+              <a:rPr lang="pt-BR" altLang="pt-BR" dirty="0"/>
+              <a:t> Superou AVL no processamento sequencial</a:t>
+            </a:r>
+          </a:p>
+          <a:p>
+            <a:pPr marL="1371600" lvl="3" indent="0" eaLnBrk="0" fontAlgn="base" hangingPunct="0">
+              <a:lnSpc>
+                <a:spcPct val="100000"/>
+              </a:lnSpc>
+              <a:spcBef>
+                <a:spcPct val="0"/>
+              </a:spcBef>
+              <a:spcAft>
+                <a:spcPct val="0"/>
+              </a:spcAft>
+              <a:buFontTx/>
+              <a:buChar char="•"/>
+            </a:pPr>
+            <a:r>
+              <a:rPr lang="pt-BR" altLang="pt-BR" sz="2000" dirty="0"/>
+              <a:t>sem overhead de rotações automáticas</a:t>
+            </a:r>
+          </a:p>
+          <a:p>
+            <a:pPr marL="914400" lvl="2" indent="0" eaLnBrk="0" fontAlgn="base" hangingPunct="0">
+              <a:lnSpc>
+                <a:spcPct val="100000"/>
+              </a:lnSpc>
+              <a:spcBef>
+                <a:spcPct val="0"/>
+              </a:spcBef>
+              <a:spcAft>
+                <a:spcPct val="0"/>
+              </a:spcAft>
+              <a:buFontTx/>
+              <a:buChar char="•"/>
+            </a:pPr>
+            <a:endParaRPr kumimoji="0" lang="pt-BR" altLang="pt-BR" sz="1800" b="1" i="0" u="none" strike="noStrike" cap="none" normalizeH="0" baseline="0" dirty="0">
+              <a:ln>
+                <a:noFill/>
+              </a:ln>
+              <a:solidFill>
+                <a:schemeClr val="tx1"/>
+              </a:solidFill>
+              <a:effectLst/>
+              <a:latin typeface="Arial" panose="020B0604020202020204" pitchFamily="34" charset="0"/>
+            </a:endParaRPr>
+          </a:p>
+          <a:p>
+            <a:pPr marL="457200" lvl="1" indent="0" eaLnBrk="0" fontAlgn="base" hangingPunct="0">
+              <a:lnSpc>
+                <a:spcPct val="100000"/>
+              </a:lnSpc>
+              <a:spcBef>
+                <a:spcPct val="0"/>
+              </a:spcBef>
+              <a:spcAft>
+                <a:spcPct val="0"/>
+              </a:spcAft>
+              <a:buFontTx/>
+              <a:buAutoNum type="arabicPeriod"/>
+            </a:pPr>
+            <a:endParaRPr kumimoji="0" lang="pt-BR" altLang="pt-BR" sz="2000" b="0" i="0" u="none" strike="noStrike" cap="none" normalizeH="0" baseline="0" dirty="0">
+              <a:ln>
+                <a:noFill/>
+              </a:ln>
+              <a:solidFill>
+                <a:schemeClr val="tx1"/>
+              </a:solidFill>
+              <a:effectLst/>
+              <a:latin typeface="Google Sans Text"/>
+            </a:endParaRPr>
+          </a:p>
+        </p:txBody>
+      </p:sp>
+    </p:spTree>
+    <p:extLst>
+      <p:ext uri="{BB962C8B-B14F-4D97-AF65-F5344CB8AC3E}">
+        <p14:creationId xmlns:p14="http://schemas.microsoft.com/office/powerpoint/2010/main" val="3227322142"/>
+      </p:ext>
+    </p:extLst>
+  </p:cSld>
+  <p:clrMapOvr>
+    <a:masterClrMapping/>
+  </p:clrMapOvr>
+</p:sld>
+</file>
+
+<file path=ppt/slides/slide11.xml><?xml version="1.0" encoding="utf-8"?>
+<p:sld xmlns:a="http://schemas.openxmlformats.org/drawingml/2006/main" xmlns:r="http://schemas.openxmlformats.org/officeDocument/2006/relationships" xmlns:p="http://schemas.openxmlformats.org/presentationml/2006/main">
+  <p:cSld>
+    <p:spTree>
+      <p:nvGrpSpPr>
+        <p:cNvPr id="1" name="">
+          <a:extLst>
+            <a:ext uri="{FF2B5EF4-FFF2-40B4-BE49-F238E27FC236}">
               <a16:creationId xmlns:a16="http://schemas.microsoft.com/office/drawing/2014/main" id="{A02D6968-D1BD-D846-D23A-50FCDDAE70F0}"/>
             </a:ext>
           </a:extLst>
@@ -4163,7 +4698,7 @@
 </p:sld>
 </file>
 
-<file path=ppt/slides/slide11.xml><?xml version="1.0" encoding="utf-8"?>
+<file path=ppt/slides/slide12.xml><?xml version="1.0" encoding="utf-8"?>
 <p:sld xmlns:a="http://schemas.openxmlformats.org/drawingml/2006/main" xmlns:r="http://schemas.openxmlformats.org/officeDocument/2006/relationships" xmlns:p="http://schemas.openxmlformats.org/presentationml/2006/main">
   <p:cSld>
     <p:spTree>
@@ -4509,7 +5044,7 @@
             </a:pPr>
             <a:r>
               <a:rPr lang="pt-BR" dirty="0"/>
-              <a:t> paralelismo</a:t>
+              <a:t> Paralelismo</a:t>
             </a:r>
           </a:p>
           <a:p>
@@ -4572,7 +5107,7 @@
             <a:pPr lvl="2"/>
             <a:r>
               <a:rPr lang="pt-BR" dirty="0"/>
-              <a:t>Para as operações naturalmente eficientes O(log N), o overhead de coordenação tornou a computação Single-Thread vitoriosa</a:t>
+              <a:t>Para as operações naturalmente eficientes O(log N), o overhead de coordenação tornou a computação Single-Thread superior</a:t>
             </a:r>
             <a:endParaRPr kumimoji="0" lang="pt-BR" altLang="pt-BR" sz="2000" b="0" i="0" u="none" strike="noStrike" cap="none" normalizeH="0" baseline="0" dirty="0">
               <a:ln>
@@ -4649,7 +5184,7 @@
 </p:sld>
 </file>
 
-<file path=ppt/slides/slide12.xml><?xml version="1.0" encoding="utf-8"?>
+<file path=ppt/slides/slide13.xml><?xml version="1.0" encoding="utf-8"?>
 <p:sld xmlns:a="http://schemas.openxmlformats.org/drawingml/2006/main" xmlns:r="http://schemas.openxmlformats.org/officeDocument/2006/relationships" xmlns:p="http://schemas.openxmlformats.org/presentationml/2006/main">
   <p:cSld>
     <p:spTree>
@@ -4915,7 +5450,7 @@
 </p:sld>
 </file>
 
-<file path=ppt/slides/slide13.xml><?xml version="1.0" encoding="utf-8"?>
+<file path=ppt/slides/slide14.xml><?xml version="1.0" encoding="utf-8"?>
 <p:sld xmlns:a="http://schemas.openxmlformats.org/drawingml/2006/main" xmlns:r="http://schemas.openxmlformats.org/officeDocument/2006/relationships" xmlns:p="http://schemas.openxmlformats.org/presentationml/2006/main">
   <p:cSld>
     <p:spTree>
@@ -5150,8 +5685,8 @@
         </p:nvSpPr>
         <p:spPr bwMode="auto">
           <a:xfrm>
-            <a:off x="838200" y="2050682"/>
-            <a:ext cx="10515600" cy="4462760"/>
+            <a:off x="838200" y="2604679"/>
+            <a:ext cx="10515600" cy="3354765"/>
           </a:xfrm>
           <a:prstGeom prst="rect">
             <a:avLst/>
@@ -5223,125 +5758,79 @@
                 <a:effectLst/>
                 <a:latin typeface="Google Sans Text"/>
               </a:rPr>
-              <a:t> A Invariância do </a:t>
-            </a:r>
-            <a:r>
-              <a:rPr kumimoji="0" lang="pt-BR" altLang="pt-BR" sz="2400" b="1" i="0" u="none" strike="noStrike" cap="none" normalizeH="0" baseline="0" dirty="0" err="1">
-                <a:ln>
-                  <a:noFill/>
-                </a:ln>
-                <a:solidFill>
-                  <a:schemeClr val="tx1"/>
-                </a:solidFill>
-                <a:effectLst/>
+              <a:t> </a:t>
+            </a:r>
+            <a:r>
+              <a:rPr lang="pt-BR" sz="2400" b="1" dirty="0">
                 <a:latin typeface="Google Sans Text"/>
               </a:rPr>
-              <a:t>Selection</a:t>
-            </a:r>
-            <a:r>
-              <a:rPr kumimoji="0" lang="pt-BR" altLang="pt-BR" sz="2400" b="1" i="0" u="none" strike="noStrike" cap="none" normalizeH="0" baseline="0" dirty="0">
-                <a:ln>
-                  <a:noFill/>
-                </a:ln>
-                <a:solidFill>
-                  <a:schemeClr val="tx1"/>
-                </a:solidFill>
-                <a:effectLst/>
+              <a:t>Topologias binárias são unidimensionais</a:t>
+            </a:r>
+          </a:p>
+          <a:p>
+            <a:pPr marL="457200" lvl="1" indent="0" eaLnBrk="0" fontAlgn="base" hangingPunct="0">
+              <a:lnSpc>
+                <a:spcPct val="100000"/>
+              </a:lnSpc>
+              <a:spcBef>
+                <a:spcPct val="0"/>
+              </a:spcBef>
+              <a:spcAft>
+                <a:spcPct val="0"/>
+              </a:spcAft>
+              <a:buFontTx/>
+              <a:buChar char="•"/>
+            </a:pPr>
+            <a:r>
+              <a:rPr lang="pt-BR" sz="2000" dirty="0">
+                <a:latin typeface="Google Sans Text"/>
+              </a:rPr>
+              <a:t> Ao buscar por um campo que não seja a chave primária de indexação, a capacidade de direcionamento lógico se perde</a:t>
+            </a:r>
+          </a:p>
+          <a:p>
+            <a:pPr marL="457200" lvl="1" indent="0" eaLnBrk="0" fontAlgn="base" hangingPunct="0">
+              <a:lnSpc>
+                <a:spcPct val="100000"/>
+              </a:lnSpc>
+              <a:spcBef>
+                <a:spcPct val="0"/>
+              </a:spcBef>
+              <a:spcAft>
+                <a:spcPct val="0"/>
+              </a:spcAft>
+              <a:buFontTx/>
+              <a:buChar char="•"/>
+            </a:pPr>
+            <a:r>
+              <a:rPr lang="pt-BR" sz="2000" dirty="0">
+                <a:latin typeface="Google Sans Text"/>
+              </a:rPr>
+              <a:t> A operação sofre uma degradação imediata para varredura completa O(N), exigindo a travessia de todos os nós (</a:t>
+            </a:r>
+            <a:r>
+              <a:rPr lang="pt-BR" sz="2000" dirty="0" err="1">
+                <a:latin typeface="Google Sans Text"/>
+              </a:rPr>
+              <a:t>Tree</a:t>
+            </a:r>
+            <a:r>
+              <a:rPr lang="pt-BR" sz="2000" dirty="0">
                 <a:latin typeface="Google Sans Text"/>
               </a:rPr>
               <a:t> </a:t>
             </a:r>
             <a:r>
-              <a:rPr kumimoji="0" lang="pt-BR" altLang="pt-BR" sz="2400" b="1" i="0" u="none" strike="noStrike" cap="none" normalizeH="0" baseline="0" dirty="0" err="1">
-                <a:ln>
-                  <a:noFill/>
-                </a:ln>
-                <a:solidFill>
-                  <a:schemeClr val="tx1"/>
-                </a:solidFill>
-                <a:effectLst/>
+              <a:rPr lang="pt-BR" sz="2000" dirty="0" err="1">
                 <a:latin typeface="Google Sans Text"/>
               </a:rPr>
-              <a:t>Sort</a:t>
-            </a:r>
-            <a:r>
-              <a:rPr kumimoji="0" lang="pt-BR" altLang="pt-BR" sz="2400" b="1" i="0" u="none" strike="noStrike" cap="none" normalizeH="0" baseline="0" dirty="0">
-                <a:ln>
-                  <a:noFill/>
-                </a:ln>
-                <a:solidFill>
-                  <a:schemeClr val="tx1"/>
-                </a:solidFill>
-                <a:effectLst/>
+              <a:t>Traversal</a:t>
+            </a:r>
+            <a:r>
+              <a:rPr lang="pt-BR" sz="2000" dirty="0">
                 <a:latin typeface="Google Sans Text"/>
               </a:rPr>
-              <a:t>:</a:t>
-            </a:r>
-            <a:r>
-              <a:rPr kumimoji="0" lang="pt-BR" altLang="pt-BR" sz="2400" b="0" i="0" u="none" strike="noStrike" cap="none" normalizeH="0" baseline="0" dirty="0">
-                <a:ln>
-                  <a:noFill/>
-                </a:ln>
-                <a:solidFill>
-                  <a:schemeClr val="tx1"/>
-                </a:solidFill>
-                <a:effectLst/>
-                <a:latin typeface="Google Sans Text"/>
-              </a:rPr>
-              <a:t> Preso na complexidade </a:t>
-            </a:r>
-            <a:r>
-              <a:rPr kumimoji="0" lang="pt-BR" altLang="pt-BR" sz="3600" b="0" i="0" u="none" strike="noStrike" cap="none" normalizeH="0" baseline="0" dirty="0">
-                <a:ln>
-                  <a:noFill/>
-                </a:ln>
-                <a:solidFill>
-                  <a:schemeClr val="tx1"/>
-                </a:solidFill>
-                <a:effectLst/>
-                <a:latin typeface="Times New Roman" panose="02020603050405020304" pitchFamily="18" charset="0"/>
-                <a:cs typeface="Times New Roman" panose="02020603050405020304" pitchFamily="18" charset="0"/>
-              </a:rPr>
-              <a:t>ɵ</a:t>
-            </a:r>
-            <a:r>
-              <a:rPr kumimoji="0" lang="pt-BR" altLang="pt-BR" sz="2400" b="0" i="0" u="none" strike="noStrike" cap="none" normalizeH="0" baseline="0" dirty="0">
-                <a:ln>
-                  <a:noFill/>
-                </a:ln>
-                <a:solidFill>
-                  <a:schemeClr val="tx1"/>
-                </a:solidFill>
-                <a:effectLst/>
-                <a:latin typeface="Google Sans Text"/>
-              </a:rPr>
-              <a:t>(n</a:t>
-            </a:r>
-            <a:r>
-              <a:rPr kumimoji="0" lang="pt-BR" altLang="pt-BR" sz="2400" b="0" i="0" u="none" strike="noStrike" cap="none" normalizeH="0" baseline="30000" dirty="0">
-                <a:ln>
-                  <a:noFill/>
-                </a:ln>
-                <a:solidFill>
-                  <a:schemeClr val="tx1"/>
-                </a:solidFill>
-                <a:effectLst/>
-                <a:latin typeface="Google Sans Text"/>
-              </a:rPr>
-              <a:t>2</a:t>
-            </a:r>
-            <a:r>
-              <a:rPr kumimoji="0" lang="pt-BR" altLang="pt-BR" sz="2400" b="0" i="0" u="none" strike="noStrike" cap="none" normalizeH="0" baseline="0" dirty="0">
-                <a:ln>
-                  <a:noFill/>
-                </a:ln>
-                <a:solidFill>
-                  <a:schemeClr val="tx1"/>
-                </a:solidFill>
-                <a:effectLst/>
-                <a:latin typeface="Google Sans Text"/>
-              </a:rPr>
-              <a:t>), não se beneficia de vetores ordenados (tempo constante nos 3 cenários)</a:t>
+              <a:t>).</a:t>
             </a:r>
           </a:p>
           <a:p>
@@ -5384,174 +5873,26 @@
               <a:buChar char="•"/>
             </a:pPr>
             <a:r>
-              <a:rPr kumimoji="0" lang="pt-BR" altLang="pt-BR" sz="2400" b="1" i="0" u="none" strike="noStrike" cap="none" normalizeH="0" baseline="0" dirty="0">
-                <a:ln>
-                  <a:noFill/>
-                </a:ln>
-                <a:solidFill>
-                  <a:schemeClr val="tx1"/>
-                </a:solidFill>
-                <a:effectLst/>
-                <a:latin typeface="Google Sans Text"/>
-              </a:rPr>
-              <a:t> O Comportamento Adaptativo do </a:t>
-            </a:r>
-            <a:r>
-              <a:rPr kumimoji="0" lang="pt-BR" altLang="pt-BR" sz="2400" b="1" i="0" u="none" strike="noStrike" cap="none" normalizeH="0" baseline="0" dirty="0" err="1">
-                <a:ln>
-                  <a:noFill/>
-                </a:ln>
-                <a:solidFill>
-                  <a:schemeClr val="tx1"/>
-                </a:solidFill>
-                <a:effectLst/>
-                <a:latin typeface="Google Sans Text"/>
-              </a:rPr>
-              <a:t>Insertion</a:t>
-            </a:r>
-            <a:r>
-              <a:rPr kumimoji="0" lang="pt-BR" altLang="pt-BR" sz="2400" b="1" i="0" u="none" strike="noStrike" cap="none" normalizeH="0" baseline="0" dirty="0">
-                <a:ln>
-                  <a:noFill/>
-                </a:ln>
-                <a:solidFill>
-                  <a:schemeClr val="tx1"/>
-                </a:solidFill>
-                <a:effectLst/>
+              <a:rPr lang="pt-BR" altLang="pt-BR" sz="2400" b="1" dirty="0">
                 <a:latin typeface="Google Sans Text"/>
               </a:rPr>
               <a:t> </a:t>
             </a:r>
             <a:r>
-              <a:rPr kumimoji="0" lang="pt-BR" altLang="pt-BR" sz="2400" b="1" i="0" u="none" strike="noStrike" cap="none" normalizeH="0" baseline="0" dirty="0" err="1">
-                <a:ln>
-                  <a:noFill/>
-                </a:ln>
-                <a:solidFill>
-                  <a:schemeClr val="tx1"/>
-                </a:solidFill>
-                <a:effectLst/>
+              <a:rPr lang="pt-BR" sz="2400" b="1" dirty="0">
                 <a:latin typeface="Google Sans Text"/>
               </a:rPr>
-              <a:t>Sort</a:t>
-            </a:r>
-            <a:r>
-              <a:rPr kumimoji="0" lang="pt-BR" altLang="pt-BR" sz="2400" b="1" i="0" u="none" strike="noStrike" cap="none" normalizeH="0" baseline="0" dirty="0">
-                <a:ln>
-                  <a:noFill/>
-                </a:ln>
-                <a:solidFill>
-                  <a:schemeClr val="tx1"/>
-                </a:solidFill>
-                <a:effectLst/>
+              <a:t>Single-Thread vs </a:t>
+            </a:r>
+            <a:r>
+              <a:rPr lang="pt-BR" sz="2400" b="1" dirty="0" err="1">
                 <a:latin typeface="Google Sans Text"/>
               </a:rPr>
-              <a:t>:</a:t>
-            </a:r>
-            <a:r>
-              <a:rPr kumimoji="0" lang="pt-BR" altLang="pt-BR" sz="2400" b="0" i="0" u="none" strike="noStrike" cap="none" normalizeH="0" baseline="0" dirty="0">
-                <a:ln>
-                  <a:noFill/>
-                </a:ln>
-                <a:solidFill>
-                  <a:schemeClr val="tx1"/>
-                </a:solidFill>
-                <a:effectLst/>
-                <a:latin typeface="Google Sans Text"/>
-              </a:rPr>
-              <a:t> Atinge o limite inferior garantido de </a:t>
-            </a:r>
-            <a:r>
-              <a:rPr kumimoji="0" lang="el-GR" altLang="pt-BR" sz="2400" b="0" i="0" u="none" strike="noStrike" cap="none" normalizeH="0" baseline="0" dirty="0">
-                <a:ln>
-                  <a:noFill/>
-                </a:ln>
-                <a:solidFill>
-                  <a:schemeClr val="tx1"/>
-                </a:solidFill>
-                <a:effectLst/>
-                <a:latin typeface="Times New Roman" panose="02020603050405020304" pitchFamily="18" charset="0"/>
-                <a:cs typeface="Times New Roman" panose="02020603050405020304" pitchFamily="18" charset="0"/>
-              </a:rPr>
-              <a:t>Ω</a:t>
-            </a:r>
-            <a:r>
-              <a:rPr kumimoji="0" lang="pt-BR" altLang="pt-BR" sz="2400" b="0" i="0" u="none" strike="noStrike" cap="none" normalizeH="0" baseline="0" dirty="0">
-                <a:ln>
-                  <a:noFill/>
-                </a:ln>
-                <a:solidFill>
-                  <a:schemeClr val="tx1"/>
-                </a:solidFill>
-                <a:effectLst/>
-                <a:latin typeface="Google Sans Text"/>
-              </a:rPr>
-              <a:t>(n) no melhor caso (~0.00s), mas sofre severa punição geométrica no pior caso.</a:t>
-            </a:r>
-          </a:p>
-          <a:p>
-            <a:pPr marL="0" indent="0" eaLnBrk="0" fontAlgn="base" hangingPunct="0">
-              <a:lnSpc>
-                <a:spcPct val="100000"/>
-              </a:lnSpc>
-              <a:spcBef>
-                <a:spcPct val="0"/>
-              </a:spcBef>
-              <a:spcAft>
-                <a:spcPct val="0"/>
-              </a:spcAft>
-              <a:buFontTx/>
-              <a:buChar char="•"/>
-            </a:pPr>
-            <a:endParaRPr kumimoji="0" lang="pt-BR" altLang="pt-BR" sz="2400" b="0" i="0" u="none" strike="noStrike" cap="none" normalizeH="0" baseline="0" dirty="0">
-              <a:ln>
-                <a:noFill/>
-              </a:ln>
-              <a:solidFill>
-                <a:schemeClr val="tx1"/>
-              </a:solidFill>
-              <a:effectLst/>
+              <a:t>Multiprocessing</a:t>
+            </a:r>
+            <a:endParaRPr lang="pt-BR" sz="2400" b="1" dirty="0">
               <a:latin typeface="Google Sans Text"/>
             </a:endParaRPr>
-          </a:p>
-          <a:p>
-            <a:pPr marL="0" indent="0" eaLnBrk="0" fontAlgn="base" hangingPunct="0">
-              <a:lnSpc>
-                <a:spcPct val="100000"/>
-              </a:lnSpc>
-              <a:spcBef>
-                <a:spcPct val="0"/>
-              </a:spcBef>
-              <a:spcAft>
-                <a:spcPct val="0"/>
-              </a:spcAft>
-              <a:buFontTx/>
-              <a:buChar char="•"/>
-            </a:pPr>
-            <a:r>
-              <a:rPr lang="pt-BR" altLang="pt-BR" sz="2400" b="1" dirty="0">
-                <a:latin typeface="Google Sans Text"/>
-              </a:rPr>
-              <a:t>Overhead do Interpretador </a:t>
-            </a:r>
-            <a:r>
-              <a:rPr lang="pt-BR" altLang="pt-BR" sz="2400" dirty="0">
-                <a:latin typeface="Google Sans Text"/>
-              </a:rPr>
-              <a:t>(</a:t>
-            </a:r>
-            <a:r>
-              <a:rPr lang="pt-BR" altLang="pt-BR" sz="2400" dirty="0" err="1">
-                <a:latin typeface="Google Sans Text"/>
-              </a:rPr>
-              <a:t>CPython</a:t>
-            </a:r>
-            <a:r>
-              <a:rPr lang="pt-BR" altLang="pt-BR" sz="2400" dirty="0">
-                <a:latin typeface="Google Sans Text"/>
-              </a:rPr>
-              <a:t>):</a:t>
-            </a:r>
           </a:p>
           <a:p>
             <a:pPr marL="457200" lvl="1" indent="0" eaLnBrk="0" fontAlgn="base" hangingPunct="0">
@@ -5568,95 +5909,25 @@
               <a:buChar char="•"/>
             </a:pPr>
             <a:r>
-              <a:rPr lang="pt-BR" altLang="pt-BR" sz="2000" dirty="0">
+              <a:rPr lang="pt-BR" sz="2000" dirty="0">
                 <a:latin typeface="Google Sans Text"/>
               </a:rPr>
-              <a:t> Os tempos brutos refletem não apenas o algoritmo, mas as limitações da linguagem: tipagem dinâmica, custo do </a:t>
-            </a:r>
-            <a:r>
-              <a:rPr lang="pt-BR" altLang="pt-BR" sz="2000" i="1" dirty="0" err="1">
+              <a:t> A varredura iterativa implementada (DFS via pilha) processou rapidamente os registros por operar essencialmente na RAM, e novamente o </a:t>
+            </a:r>
+            <a:r>
+              <a:rPr lang="pt-BR" sz="2000" dirty="0" err="1">
                 <a:latin typeface="Google Sans Text"/>
               </a:rPr>
-              <a:t>call</a:t>
-            </a:r>
-            <a:r>
-              <a:rPr lang="pt-BR" altLang="pt-BR" sz="2000" i="1" dirty="0">
+              <a:t>Multiprocessing</a:t>
+            </a:r>
+            <a:r>
+              <a:rPr lang="pt-BR" sz="2000" dirty="0">
                 <a:latin typeface="Google Sans Text"/>
               </a:rPr>
-              <a:t> </a:t>
-            </a:r>
-            <a:r>
-              <a:rPr lang="pt-BR" altLang="pt-BR" sz="2000" i="1" dirty="0" err="1">
-                <a:latin typeface="Google Sans Text"/>
-              </a:rPr>
-              <a:t>stack</a:t>
-            </a:r>
-            <a:r>
-              <a:rPr lang="pt-BR" altLang="pt-BR" sz="2000" i="1" dirty="0">
-                <a:latin typeface="Google Sans Text"/>
-              </a:rPr>
-              <a:t> </a:t>
-            </a:r>
-            <a:r>
-              <a:rPr lang="pt-BR" altLang="pt-BR" sz="2000" dirty="0">
-                <a:latin typeface="Google Sans Text"/>
-              </a:rPr>
-              <a:t>(recursão profunda) e laços interpretados.</a:t>
-            </a:r>
-          </a:p>
-          <a:p>
-            <a:pPr marL="457200" lvl="1" indent="0" eaLnBrk="0" fontAlgn="base" hangingPunct="0">
-              <a:lnSpc>
-                <a:spcPct val="100000"/>
-              </a:lnSpc>
-              <a:spcBef>
-                <a:spcPct val="0"/>
-              </a:spcBef>
-              <a:spcAft>
-                <a:spcPct val="0"/>
-              </a:spcAft>
-              <a:buFontTx/>
-              <a:buChar char="•"/>
-            </a:pPr>
-            <a:r>
-              <a:rPr lang="pt-BR" altLang="pt-BR" sz="2000" dirty="0">
-                <a:latin typeface="Google Sans Text"/>
-              </a:rPr>
-              <a:t> O </a:t>
-            </a:r>
-            <a:r>
-              <a:rPr lang="pt-BR" altLang="pt-BR" sz="2000" dirty="0" err="1">
-                <a:latin typeface="Google Sans Text"/>
-              </a:rPr>
-              <a:t>list.sort</a:t>
-            </a:r>
-            <a:r>
-              <a:rPr lang="pt-BR" altLang="pt-BR" sz="2000" dirty="0">
-                <a:latin typeface="Google Sans Text"/>
-              </a:rPr>
-              <a:t>() nativo (</a:t>
-            </a:r>
-            <a:r>
-              <a:rPr lang="pt-BR" altLang="pt-BR" sz="2000" dirty="0" err="1">
-                <a:latin typeface="Google Sans Text"/>
-              </a:rPr>
-              <a:t>Timsort</a:t>
-            </a:r>
-            <a:r>
-              <a:rPr lang="pt-BR" altLang="pt-BR" sz="2000" dirty="0">
-                <a:latin typeface="Google Sans Text"/>
-              </a:rPr>
-              <a:t>) é exponencialmente mais rápido por ser compilado em C, delegando operações diretamente ao hardware.</a:t>
-            </a:r>
-            <a:endParaRPr kumimoji="0" lang="pt-BR" altLang="pt-BR" sz="1800" b="0" i="0" u="none" strike="noStrike" cap="none" normalizeH="0" baseline="0" dirty="0">
-              <a:ln>
-                <a:noFill/>
-              </a:ln>
-              <a:solidFill>
-                <a:schemeClr val="tx1"/>
-              </a:solidFill>
-              <a:effectLst/>
-              <a:latin typeface="Arial" panose="020B0604020202020204" pitchFamily="34" charset="0"/>
+              <a:t> causou regressão severa pelos custos de serialização e IPC</a:t>
+            </a:r>
+            <a:endParaRPr lang="pt-BR" altLang="pt-BR" sz="2000" dirty="0">
+              <a:latin typeface="Google Sans Text"/>
             </a:endParaRPr>
           </a:p>
         </p:txBody>
@@ -5805,7 +6076,7 @@
 </p:sld>
 </file>
 
-<file path=ppt/slides/slide14.xml><?xml version="1.0" encoding="utf-8"?>
+<file path=ppt/slides/slide15.xml><?xml version="1.0" encoding="utf-8"?>
 <p:sld xmlns:a="http://schemas.openxmlformats.org/drawingml/2006/main" xmlns:r="http://schemas.openxmlformats.org/officeDocument/2006/relationships" xmlns:p="http://schemas.openxmlformats.org/presentationml/2006/main">
   <p:cSld>
     <p:spTree>
@@ -5828,6 +6099,43 @@
           <a:chExt cx="0" cy="0"/>
         </a:xfrm>
       </p:grpSpPr>
+      <p:sp>
+        <p:nvSpPr>
+          <p:cNvPr id="16" name="Título 1">
+            <a:extLst>
+              <a:ext uri="{FF2B5EF4-FFF2-40B4-BE49-F238E27FC236}">
+                <a16:creationId xmlns:a16="http://schemas.microsoft.com/office/drawing/2014/main" id="{B1E829A6-DEDD-FB0A-ECB6-BAFBC1D5EEE1}"/>
+              </a:ext>
+            </a:extLst>
+          </p:cNvPr>
+          <p:cNvSpPr>
+            <a:spLocks noGrp="1"/>
+          </p:cNvSpPr>
+          <p:nvPr>
+            <p:ph type="title"/>
+          </p:nvPr>
+        </p:nvSpPr>
+        <p:spPr>
+          <a:xfrm>
+            <a:off x="474860" y="1162843"/>
+            <a:ext cx="10515600" cy="1325563"/>
+          </a:xfrm>
+        </p:spPr>
+        <p:txBody>
+          <a:bodyPr>
+            <a:normAutofit/>
+          </a:bodyPr>
+          <a:lstStyle/>
+          <a:p>
+            <a:r>
+              <a:rPr lang="pt-BR" sz="2800" b="1" dirty="0">
+                <a:latin typeface="+mn-lt"/>
+              </a:rPr>
+              <a:t>Considerações Finais e Alternativas Híbridas </a:t>
+            </a:r>
+          </a:p>
+        </p:txBody>
+      </p:sp>
       <p:pic>
         <p:nvPicPr>
           <p:cNvPr id="5" name="Imagem 4">
@@ -6040,8 +6348,8 @@
         </p:nvSpPr>
         <p:spPr bwMode="auto">
           <a:xfrm>
-            <a:off x="838200" y="2248959"/>
-            <a:ext cx="10515600" cy="3908762"/>
+            <a:off x="838200" y="2455939"/>
+            <a:ext cx="10515600" cy="3494803"/>
           </a:xfrm>
           <a:prstGeom prst="rect">
             <a:avLst/>
@@ -6089,326 +6397,142 @@
           </a:bodyPr>
           <a:lstStyle/>
           <a:p>
-            <a:pPr marL="0" indent="0" eaLnBrk="0" fontAlgn="base" hangingPunct="0">
-              <a:lnSpc>
-                <a:spcPct val="100000"/>
-              </a:lnSpc>
-              <a:spcBef>
-                <a:spcPct val="0"/>
-              </a:spcBef>
-              <a:spcAft>
-                <a:spcPct val="0"/>
-              </a:spcAft>
-              <a:buFontTx/>
-              <a:buChar char="•"/>
-            </a:pPr>
-            <a:r>
-              <a:rPr kumimoji="0" lang="pt-BR" altLang="pt-BR" sz="2400" b="1" i="0" u="none" strike="noStrike" cap="none" normalizeH="0" baseline="0" dirty="0">
-                <a:ln>
-                  <a:noFill/>
-                </a:ln>
-                <a:solidFill>
-                  <a:schemeClr val="tx1"/>
-                </a:solidFill>
-                <a:effectLst/>
+            <a:pPr lvl="0"/>
+            <a:r>
+              <a:rPr lang="pt-BR" sz="2000" dirty="0">
                 <a:latin typeface="Google Sans Text"/>
               </a:rPr>
-              <a:t>Validação Teórica:</a:t>
-            </a:r>
-            <a:r>
-              <a:rPr kumimoji="0" lang="pt-BR" altLang="pt-BR" sz="2400" b="0" i="0" u="none" strike="noStrike" cap="none" normalizeH="0" baseline="0" dirty="0">
-                <a:ln>
-                  <a:noFill/>
-                </a:ln>
-                <a:solidFill>
-                  <a:schemeClr val="tx1"/>
-                </a:solidFill>
-                <a:effectLst/>
+              <a:t>Para </a:t>
+            </a:r>
+            <a:r>
+              <a:rPr lang="pt-BR" sz="2000" b="1" dirty="0">
                 <a:latin typeface="Google Sans Text"/>
               </a:rPr>
-              <a:t> Os experimentos corroboram a teoria matemática; algoritmos O(n</a:t>
-            </a:r>
-            <a:r>
-              <a:rPr kumimoji="0" lang="pt-BR" altLang="pt-BR" sz="2400" b="0" i="0" u="none" strike="noStrike" cap="none" normalizeH="0" baseline="30000" dirty="0">
-                <a:ln>
-                  <a:noFill/>
-                </a:ln>
-                <a:solidFill>
-                  <a:schemeClr val="tx1"/>
-                </a:solidFill>
-                <a:effectLst/>
+              <a:t>cenários produtivos </a:t>
+            </a:r>
+            <a:r>
+              <a:rPr lang="pt-BR" sz="2000" dirty="0">
                 <a:latin typeface="Google Sans Text"/>
               </a:rPr>
-              <a:t>2</a:t>
-            </a:r>
-            <a:r>
-              <a:rPr kumimoji="0" lang="pt-BR" altLang="pt-BR" sz="2400" b="0" i="0" u="none" strike="noStrike" cap="none" normalizeH="0" baseline="0" dirty="0">
-                <a:ln>
-                  <a:noFill/>
-                </a:ln>
-                <a:solidFill>
-                  <a:schemeClr val="tx1"/>
-                </a:solidFill>
-                <a:effectLst/>
+              <a:t>reais:</a:t>
+            </a:r>
+          </a:p>
+          <a:p>
+            <a:pPr lvl="1"/>
+            <a:r>
+              <a:rPr lang="pt-BR" sz="2000" dirty="0">
                 <a:latin typeface="Google Sans Text"/>
               </a:rPr>
-              <a:t>) sofrem degradação drástica em instâncias massivas.</a:t>
-            </a:r>
-          </a:p>
-          <a:p>
-            <a:pPr marL="0" indent="0" eaLnBrk="0" fontAlgn="base" hangingPunct="0">
-              <a:lnSpc>
-                <a:spcPct val="100000"/>
-              </a:lnSpc>
-              <a:spcBef>
-                <a:spcPct val="0"/>
-              </a:spcBef>
-              <a:spcAft>
-                <a:spcPct val="0"/>
-              </a:spcAft>
-              <a:buFontTx/>
-              <a:buChar char="•"/>
-            </a:pPr>
-            <a:endParaRPr kumimoji="0" lang="pt-BR" altLang="pt-BR" sz="2400" b="0" i="0" u="none" strike="noStrike" cap="none" normalizeH="0" baseline="0" dirty="0">
-              <a:ln>
-                <a:noFill/>
-              </a:ln>
-              <a:solidFill>
-                <a:schemeClr val="tx1"/>
-              </a:solidFill>
-              <a:effectLst/>
+              <a:t> Varreduras O(N) são ineficientes em alta escala. </a:t>
+            </a:r>
+          </a:p>
+          <a:p>
+            <a:pPr lvl="2"/>
+            <a:r>
+              <a:rPr lang="pt-BR" dirty="0">
+                <a:latin typeface="Google Sans Text"/>
+              </a:rPr>
+              <a:t>A melhor solução arquitetural é associar a árvore a Índices Secundários baseados em </a:t>
+            </a:r>
+            <a:r>
+              <a:rPr lang="pt-BR" dirty="0" err="1">
+                <a:latin typeface="Google Sans Text"/>
+              </a:rPr>
+              <a:t>Hash</a:t>
+            </a:r>
+            <a:r>
+              <a:rPr lang="pt-BR" dirty="0">
+                <a:latin typeface="Google Sans Text"/>
+              </a:rPr>
+              <a:t> Maps (dicionários com custo O(1))</a:t>
+            </a:r>
+          </a:p>
+          <a:p>
+            <a:pPr lvl="0"/>
+            <a:r>
+              <a:rPr lang="pt-BR" sz="2000" dirty="0">
+                <a:latin typeface="Google Sans Text"/>
+              </a:rPr>
+              <a:t>A </a:t>
+            </a:r>
+            <a:r>
+              <a:rPr lang="pt-BR" sz="2000" b="1" dirty="0">
+                <a:latin typeface="Google Sans Text"/>
+              </a:rPr>
+              <a:t>eficiência algorítmica </a:t>
+            </a:r>
+            <a:r>
+              <a:rPr lang="pt-BR" sz="2000" dirty="0">
+                <a:latin typeface="Google Sans Text"/>
+              </a:rPr>
+              <a:t>depende da </a:t>
+            </a:r>
+            <a:r>
+              <a:rPr lang="pt-BR" sz="2000" b="1" dirty="0">
+                <a:latin typeface="Google Sans Text"/>
+              </a:rPr>
+              <a:t>metodologia</a:t>
+            </a:r>
+            <a:r>
+              <a:rPr lang="pt-BR" sz="2000" dirty="0">
+                <a:latin typeface="Google Sans Text"/>
+              </a:rPr>
+              <a:t> aplicada e também da </a:t>
+            </a:r>
+            <a:r>
+              <a:rPr lang="pt-BR" sz="2000" b="1" dirty="0">
+                <a:latin typeface="Google Sans Text"/>
+              </a:rPr>
+              <a:t>entropia dos dados </a:t>
+            </a:r>
+            <a:r>
+              <a:rPr lang="pt-BR" sz="2000" dirty="0">
+                <a:latin typeface="Google Sans Text"/>
+              </a:rPr>
+              <a:t>e de </a:t>
+            </a:r>
+            <a:r>
+              <a:rPr lang="pt-BR" sz="2000" u="sng" dirty="0">
+                <a:latin typeface="Google Sans Text"/>
+              </a:rPr>
+              <a:t>custos ocultos do ambiente</a:t>
+            </a:r>
+            <a:r>
+              <a:rPr lang="pt-BR" sz="2000" dirty="0">
+                <a:latin typeface="Google Sans Text"/>
+              </a:rPr>
+              <a:t>.</a:t>
+            </a:r>
+          </a:p>
+          <a:p>
+            <a:pPr lvl="0"/>
+            <a:r>
+              <a:rPr lang="pt-BR" sz="2000" dirty="0">
+                <a:latin typeface="Google Sans Text"/>
+              </a:rPr>
+              <a:t>A força bruta computacional não substitui o </a:t>
+            </a:r>
+            <a:r>
+              <a:rPr lang="pt-BR" sz="2000" b="1" dirty="0">
+                <a:latin typeface="Google Sans Text"/>
+              </a:rPr>
+              <a:t>planejamento matemático algorítmico</a:t>
+            </a:r>
+          </a:p>
+          <a:p>
+            <a:pPr lvl="1"/>
+            <a:r>
+              <a:rPr lang="pt-BR" sz="2000" dirty="0">
+                <a:latin typeface="Google Sans Text"/>
+              </a:rPr>
+              <a:t>Paralelizar processos ineficientes pode atenuar o problema, mas não corrige a ineficiência intrínseca</a:t>
+            </a:r>
+          </a:p>
+          <a:p>
+            <a:pPr lvl="0"/>
+            <a:endParaRPr lang="pt-BR" sz="2400" dirty="0">
               <a:latin typeface="Google Sans Text"/>
             </a:endParaRPr>
-          </a:p>
-          <a:p>
-            <a:pPr marL="0" lvl="0" indent="0" eaLnBrk="0" fontAlgn="base" hangingPunct="0">
-              <a:lnSpc>
-                <a:spcPct val="100000"/>
-              </a:lnSpc>
-              <a:spcBef>
-                <a:spcPct val="0"/>
-              </a:spcBef>
-              <a:spcAft>
-                <a:spcPct val="0"/>
-              </a:spcAft>
-              <a:buFontTx/>
-              <a:buChar char="•"/>
-            </a:pPr>
-            <a:r>
-              <a:rPr kumimoji="0" lang="pt-BR" altLang="pt-BR" sz="2400" b="1" i="0" u="none" strike="noStrike" cap="none" normalizeH="0" baseline="0" dirty="0">
-                <a:ln>
-                  <a:noFill/>
-                </a:ln>
-                <a:solidFill>
-                  <a:schemeClr val="tx1"/>
-                </a:solidFill>
-                <a:effectLst/>
-                <a:latin typeface="Google Sans Text"/>
-              </a:rPr>
-              <a:t>A Escolha Pragmática:</a:t>
-            </a:r>
-            <a:r>
-              <a:rPr kumimoji="0" lang="pt-BR" altLang="pt-BR" sz="2400" b="0" i="0" u="none" strike="noStrike" cap="none" normalizeH="0" baseline="0" dirty="0">
-                <a:ln>
-                  <a:noFill/>
-                </a:ln>
-                <a:solidFill>
-                  <a:schemeClr val="tx1"/>
-                </a:solidFill>
-                <a:effectLst/>
-                <a:latin typeface="Google Sans Text"/>
-              </a:rPr>
-              <a:t> A decisão arquitetural não deve se basear apenas na classe </a:t>
-            </a:r>
-            <a:r>
-              <a:rPr kumimoji="0" lang="pt-BR" altLang="pt-BR" sz="2400" b="0" i="0" u="none" strike="noStrike" cap="none" normalizeH="0" baseline="0" dirty="0" err="1">
-                <a:ln>
-                  <a:noFill/>
-                </a:ln>
-                <a:solidFill>
-                  <a:schemeClr val="tx1"/>
-                </a:solidFill>
-                <a:effectLst/>
-                <a:latin typeface="Google Sans Text"/>
-              </a:rPr>
-              <a:t>Big-O</a:t>
-            </a:r>
-            <a:r>
-              <a:rPr kumimoji="0" lang="pt-BR" altLang="pt-BR" sz="2400" b="0" i="0" u="none" strike="noStrike" cap="none" normalizeH="0" baseline="0" dirty="0">
-                <a:ln>
-                  <a:noFill/>
-                </a:ln>
-                <a:solidFill>
-                  <a:schemeClr val="tx1"/>
-                </a:solidFill>
-                <a:effectLst/>
-                <a:latin typeface="Google Sans Text"/>
-              </a:rPr>
-              <a:t>, mas exige a ponderação de:</a:t>
-            </a:r>
-          </a:p>
-          <a:p>
-            <a:pPr marL="457200" lvl="1" indent="0" eaLnBrk="0" fontAlgn="base" hangingPunct="0">
-              <a:lnSpc>
-                <a:spcPct val="100000"/>
-              </a:lnSpc>
-              <a:spcBef>
-                <a:spcPct val="0"/>
-              </a:spcBef>
-              <a:spcAft>
-                <a:spcPct val="0"/>
-              </a:spcAft>
-              <a:buFontTx/>
-              <a:buAutoNum type="arabicPeriod"/>
-            </a:pPr>
-            <a:r>
-              <a:rPr lang="pt-BR" altLang="pt-BR" sz="2000" b="1" dirty="0">
-                <a:latin typeface="Google Sans Text"/>
-              </a:rPr>
-              <a:t>Estabilidade</a:t>
-            </a:r>
-            <a:r>
-              <a:rPr lang="pt-BR" altLang="pt-BR" sz="2000" dirty="0">
-                <a:latin typeface="Google Sans Text"/>
-              </a:rPr>
-              <a:t>: Preservação do histórico de dados.</a:t>
-            </a:r>
-          </a:p>
-          <a:p>
-            <a:pPr marL="457200" lvl="1" indent="0" eaLnBrk="0" fontAlgn="base" hangingPunct="0">
-              <a:lnSpc>
-                <a:spcPct val="100000"/>
-              </a:lnSpc>
-              <a:spcBef>
-                <a:spcPct val="0"/>
-              </a:spcBef>
-              <a:spcAft>
-                <a:spcPct val="0"/>
-              </a:spcAft>
-              <a:buFontTx/>
-              <a:buAutoNum type="arabicPeriod" startAt="2"/>
-            </a:pPr>
-            <a:r>
-              <a:rPr lang="pt-BR" altLang="pt-BR" sz="2000" b="1" dirty="0">
-                <a:latin typeface="Google Sans Text"/>
-              </a:rPr>
-              <a:t>Complexidade Espacial</a:t>
-            </a:r>
-            <a:r>
-              <a:rPr lang="pt-BR" altLang="pt-BR" sz="2000" dirty="0">
-                <a:latin typeface="Google Sans Text"/>
-              </a:rPr>
-              <a:t>: Economia de memória x velocidade de processamento.</a:t>
-            </a:r>
-          </a:p>
-          <a:p>
-            <a:pPr marL="457200" lvl="1" indent="0" eaLnBrk="0" fontAlgn="base" hangingPunct="0">
-              <a:lnSpc>
-                <a:spcPct val="100000"/>
-              </a:lnSpc>
-              <a:spcBef>
-                <a:spcPct val="0"/>
-              </a:spcBef>
-              <a:spcAft>
-                <a:spcPct val="0"/>
-              </a:spcAft>
-              <a:buFontTx/>
-              <a:buAutoNum type="arabicPeriod" startAt="3"/>
-            </a:pPr>
-            <a:r>
-              <a:rPr lang="pt-BR" altLang="pt-BR" sz="2000" b="1" dirty="0">
-                <a:latin typeface="Google Sans Text"/>
-              </a:rPr>
-              <a:t>Sensibilidade Topológica</a:t>
-            </a:r>
-            <a:r>
-              <a:rPr lang="pt-BR" altLang="pt-BR" sz="2000" dirty="0">
-                <a:latin typeface="Google Sans Text"/>
-              </a:rPr>
-              <a:t>: Comportamento diante da ordenação prévia dos dados.</a:t>
-            </a:r>
-          </a:p>
-          <a:p>
-            <a:pPr marL="457200" lvl="1" indent="0" eaLnBrk="0" fontAlgn="base" hangingPunct="0">
-              <a:lnSpc>
-                <a:spcPct val="100000"/>
-              </a:lnSpc>
-              <a:spcBef>
-                <a:spcPct val="0"/>
-              </a:spcBef>
-              <a:spcAft>
-                <a:spcPct val="0"/>
-              </a:spcAft>
-              <a:buFontTx/>
-              <a:buAutoNum type="arabicPeriod" startAt="3"/>
-            </a:pPr>
-            <a:endParaRPr lang="pt-BR" altLang="pt-BR" sz="2000" dirty="0">
-              <a:latin typeface="Google Sans Text"/>
-            </a:endParaRPr>
-          </a:p>
-          <a:p>
-            <a:pPr marL="0" indent="0" eaLnBrk="0" fontAlgn="base" hangingPunct="0">
-              <a:lnSpc>
-                <a:spcPct val="100000"/>
-              </a:lnSpc>
-              <a:spcBef>
-                <a:spcPct val="0"/>
-              </a:spcBef>
-              <a:spcAft>
-                <a:spcPct val="0"/>
-              </a:spcAft>
-              <a:buFontTx/>
-              <a:buAutoNum type="arabicPeriod" startAt="3"/>
-            </a:pPr>
-            <a:r>
-              <a:rPr lang="pt-BR" altLang="pt-BR" sz="2400" b="1" dirty="0">
-                <a:latin typeface="Google Sans Text"/>
-              </a:rPr>
-              <a:t>Síntese: </a:t>
-            </a:r>
-            <a:r>
-              <a:rPr lang="pt-BR" altLang="pt-BR" sz="2400" dirty="0">
-                <a:latin typeface="Google Sans Text"/>
-              </a:rPr>
-              <a:t>A análise formal de algoritmos é uma ferramenta pragmática e essencial para a construção de sistemas escaláveis e verdadeiramente otimizados.</a:t>
-            </a:r>
-          </a:p>
-        </p:txBody>
-      </p:sp>
-      <p:sp>
-        <p:nvSpPr>
-          <p:cNvPr id="16" name="Título 1">
-            <a:extLst>
-              <a:ext uri="{FF2B5EF4-FFF2-40B4-BE49-F238E27FC236}">
-                <a16:creationId xmlns:a16="http://schemas.microsoft.com/office/drawing/2014/main" id="{B1E829A6-DEDD-FB0A-ECB6-BAFBC1D5EEE1}"/>
-              </a:ext>
-            </a:extLst>
-          </p:cNvPr>
-          <p:cNvSpPr>
-            <a:spLocks noGrp="1"/>
-          </p:cNvSpPr>
-          <p:nvPr>
-            <p:ph type="title"/>
-          </p:nvPr>
-        </p:nvSpPr>
-        <p:spPr>
-          <a:xfrm>
-            <a:off x="474860" y="1162843"/>
-            <a:ext cx="10515600" cy="1325563"/>
-          </a:xfrm>
-        </p:spPr>
-        <p:txBody>
-          <a:bodyPr>
-            <a:normAutofit/>
-          </a:bodyPr>
-          <a:lstStyle/>
-          <a:p>
-            <a:r>
-              <a:rPr lang="pt-BR" sz="2800" b="1" dirty="0">
-                <a:latin typeface="+mn-lt"/>
-              </a:rPr>
-              <a:t>Considerações Finais e Engenharia de Software</a:t>
-            </a:r>
           </a:p>
         </p:txBody>
       </p:sp>
@@ -6425,7 +6549,7 @@
 </p:sld>
 </file>
 
-<file path=ppt/slides/slide15.xml><?xml version="1.0" encoding="utf-8"?>
+<file path=ppt/slides/slide16.xml><?xml version="1.0" encoding="utf-8"?>
 <p:sld xmlns:a="http://schemas.openxmlformats.org/drawingml/2006/main" xmlns:r="http://schemas.openxmlformats.org/officeDocument/2006/relationships" xmlns:p="http://schemas.openxmlformats.org/presentationml/2006/main">
   <p:cSld>
     <p:spTree>
@@ -7284,8 +7408,8 @@
         </p:nvSpPr>
         <p:spPr bwMode="auto">
           <a:xfrm>
-            <a:off x="949720" y="2107438"/>
-            <a:ext cx="10515600" cy="4524315"/>
+            <a:off x="949720" y="2292103"/>
+            <a:ext cx="10515600" cy="4154984"/>
           </a:xfrm>
           <a:prstGeom prst="rect">
             <a:avLst/>
@@ -7373,7 +7497,7 @@
             </a:pPr>
             <a:r>
               <a:rPr lang="pt-BR" dirty="0"/>
-              <a:t>A eficiência das estruturas de dados na prática é influenciada não apenas pelo limite matemático teórico, mas pela entropia dos dados de entrada e pelo custo oculto do ambiente de execução</a:t>
+              <a:t> Avaliar o impacto das árvores de pesquisa e da topologia prévia dos dados no tempo de execução/inserção</a:t>
             </a:r>
           </a:p>
           <a:p>
@@ -7390,10 +7514,7 @@
               <a:buFontTx/>
               <a:buChar char="•"/>
             </a:pPr>
-            <a:endParaRPr lang="pt-BR" altLang="pt-BR" b="1" dirty="0">
-              <a:ea typeface="+mj-ea"/>
-              <a:cs typeface="+mj-cs"/>
-            </a:endParaRPr>
+            <a:endParaRPr lang="pt-BR" dirty="0"/>
           </a:p>
           <a:p>
             <a:pPr marL="0" marR="0" lvl="0" indent="0" algn="l" defTabSz="914400" rtl="0" eaLnBrk="0" fontAlgn="base" latinLnBrk="0" hangingPunct="0">
@@ -7443,7 +7564,7 @@
             </a:r>
             <a:r>
               <a:rPr lang="pt-BR" dirty="0"/>
-              <a:t>Executar testes de benchmarking para quantificar o impacto da paralelização e da topologia dos dados sobre o tempo de busca em árvores de pesquisa</a:t>
+              <a:t>Executar testes de benchmarking para quantificar o impacto das árvores de pesquisa e da topologia prévia dos dados</a:t>
             </a:r>
           </a:p>
           <a:p>
@@ -7460,13 +7581,10 @@
               <a:buFontTx/>
               <a:buChar char="•"/>
             </a:pPr>
-            <a:endParaRPr lang="pt-BR" altLang="pt-BR" b="1" dirty="0">
-              <a:ea typeface="+mj-ea"/>
-              <a:cs typeface="+mj-cs"/>
-            </a:endParaRPr>
-          </a:p>
-          <a:p>
-            <a:pPr marL="0" marR="0" lvl="0" indent="0" algn="l" defTabSz="914400" rtl="0" eaLnBrk="0" fontAlgn="base" latinLnBrk="0" hangingPunct="0">
+            <a:endParaRPr lang="pt-BR" dirty="0"/>
+          </a:p>
+          <a:p>
+            <a:pPr marL="0" lvl="0" indent="0" eaLnBrk="0" fontAlgn="base" hangingPunct="0">
               <a:lnSpc>
                 <a:spcPct val="100000"/>
               </a:lnSpc>
@@ -7476,11 +7594,8 @@
               <a:spcAft>
                 <a:spcPct val="0"/>
               </a:spcAft>
-              <a:buClrTx/>
-              <a:buSzTx/>
               <a:buFontTx/>
               <a:buChar char="•"/>
-              <a:tabLst/>
             </a:pPr>
             <a:r>
               <a:rPr lang="pt-BR" altLang="pt-BR" sz="2400" b="1" dirty="0">
@@ -8984,6 +9099,309 @@
         <p:cNvPr id="1" name="">
           <a:extLst>
             <a:ext uri="{FF2B5EF4-FFF2-40B4-BE49-F238E27FC236}">
+              <a16:creationId xmlns:a16="http://schemas.microsoft.com/office/drawing/2014/main" id="{AD7E254D-7C30-226F-46B1-60A90E756696}"/>
+            </a:ext>
+          </a:extLst>
+        </p:cNvPr>
+        <p:cNvGrpSpPr/>
+        <p:nvPr/>
+      </p:nvGrpSpPr>
+      <p:grpSpPr>
+        <a:xfrm>
+          <a:off x="0" y="0"/>
+          <a:ext cx="0" cy="0"/>
+          <a:chOff x="0" y="0"/>
+          <a:chExt cx="0" cy="0"/>
+        </a:xfrm>
+      </p:grpSpPr>
+      <p:pic>
+        <p:nvPicPr>
+          <p:cNvPr id="5" name="Imagem 4">
+            <a:extLst>
+              <a:ext uri="{FF2B5EF4-FFF2-40B4-BE49-F238E27FC236}">
+                <a16:creationId xmlns:a16="http://schemas.microsoft.com/office/drawing/2014/main" id="{C1C31EDC-F49A-C0AA-82CF-57499F4C0E9A}"/>
+              </a:ext>
+            </a:extLst>
+          </p:cNvPr>
+          <p:cNvPicPr>
+            <a:picLocks noChangeAspect="1"/>
+          </p:cNvPicPr>
+          <p:nvPr/>
+        </p:nvPicPr>
+        <p:blipFill>
+          <a:blip r:embed="rId2"/>
+          <a:stretch>
+            <a:fillRect/>
+          </a:stretch>
+        </p:blipFill>
+        <p:spPr>
+          <a:xfrm>
+            <a:off x="0" y="0"/>
+            <a:ext cx="12192000" cy="1398060"/>
+          </a:xfrm>
+          <a:prstGeom prst="rect">
+            <a:avLst/>
+          </a:prstGeom>
+        </p:spPr>
+      </p:pic>
+      <p:grpSp>
+        <p:nvGrpSpPr>
+          <p:cNvPr id="10" name="Agrupar 9">
+            <a:extLst>
+              <a:ext uri="{FF2B5EF4-FFF2-40B4-BE49-F238E27FC236}">
+                <a16:creationId xmlns:a16="http://schemas.microsoft.com/office/drawing/2014/main" id="{737DE06F-78E9-42EF-F7B2-BD4FDF6616EE}"/>
+              </a:ext>
+            </a:extLst>
+          </p:cNvPr>
+          <p:cNvGrpSpPr/>
+          <p:nvPr/>
+        </p:nvGrpSpPr>
+        <p:grpSpPr>
+          <a:xfrm>
+            <a:off x="4739781" y="3585812"/>
+            <a:ext cx="7452219" cy="3272188"/>
+            <a:chOff x="4739781" y="3585812"/>
+            <a:chExt cx="7452219" cy="3272188"/>
+          </a:xfrm>
+        </p:grpSpPr>
+        <p:pic>
+          <p:nvPicPr>
+            <p:cNvPr id="7" name="Imagem 6">
+              <a:extLst>
+                <a:ext uri="{FF2B5EF4-FFF2-40B4-BE49-F238E27FC236}">
+                  <a16:creationId xmlns:a16="http://schemas.microsoft.com/office/drawing/2014/main" id="{837EF829-EABB-20FA-D9BF-B2774A6A87C3}"/>
+                </a:ext>
+              </a:extLst>
+            </p:cNvPr>
+            <p:cNvPicPr>
+              <a:picLocks noChangeAspect="1"/>
+            </p:cNvPicPr>
+            <p:nvPr/>
+          </p:nvPicPr>
+          <p:blipFill>
+            <a:blip r:embed="rId3"/>
+            <a:stretch>
+              <a:fillRect/>
+            </a:stretch>
+          </p:blipFill>
+          <p:spPr>
+            <a:xfrm>
+              <a:off x="5492514" y="4013377"/>
+              <a:ext cx="6699486" cy="2844623"/>
+            </a:xfrm>
+            <a:prstGeom prst="rect">
+              <a:avLst/>
+            </a:prstGeom>
+            <a:effectLst>
+              <a:outerShdw blurRad="50800" dist="50800" dir="5400000" algn="ctr" rotWithShape="0">
+                <a:srgbClr val="000000"/>
+              </a:outerShdw>
+            </a:effectLst>
+          </p:spPr>
+        </p:pic>
+        <p:sp>
+          <p:nvSpPr>
+            <p:cNvPr id="8" name="Retângulo 7">
+              <a:extLst>
+                <a:ext uri="{FF2B5EF4-FFF2-40B4-BE49-F238E27FC236}">
+                  <a16:creationId xmlns:a16="http://schemas.microsoft.com/office/drawing/2014/main" id="{19DC2AC7-9A42-0858-AE50-9DA8AC7EC297}"/>
+                </a:ext>
+              </a:extLst>
+            </p:cNvPr>
+            <p:cNvSpPr/>
+            <p:nvPr/>
+          </p:nvSpPr>
+          <p:spPr>
+            <a:xfrm>
+              <a:off x="4739781" y="4013377"/>
+              <a:ext cx="1104550" cy="2844623"/>
+            </a:xfrm>
+            <a:prstGeom prst="rect">
+              <a:avLst/>
+            </a:prstGeom>
+            <a:solidFill>
+              <a:schemeClr val="bg1"/>
+            </a:solidFill>
+            <a:ln>
+              <a:solidFill>
+                <a:schemeClr val="bg1"/>
+              </a:solidFill>
+            </a:ln>
+          </p:spPr>
+          <p:style>
+            <a:lnRef idx="2">
+              <a:schemeClr val="accent1">
+                <a:shade val="15000"/>
+              </a:schemeClr>
+            </a:lnRef>
+            <a:fillRef idx="1">
+              <a:schemeClr val="accent1"/>
+            </a:fillRef>
+            <a:effectRef idx="0">
+              <a:schemeClr val="accent1"/>
+            </a:effectRef>
+            <a:fontRef idx="minor">
+              <a:schemeClr val="lt1"/>
+            </a:fontRef>
+          </p:style>
+          <p:txBody>
+            <a:bodyPr rtlCol="0" anchor="ctr"/>
+            <a:lstStyle/>
+            <a:p>
+              <a:pPr algn="ctr"/>
+              <a:endParaRPr lang="pt-BR"/>
+            </a:p>
+          </p:txBody>
+        </p:sp>
+        <p:sp>
+          <p:nvSpPr>
+            <p:cNvPr id="9" name="Retângulo 8">
+              <a:extLst>
+                <a:ext uri="{FF2B5EF4-FFF2-40B4-BE49-F238E27FC236}">
+                  <a16:creationId xmlns:a16="http://schemas.microsoft.com/office/drawing/2014/main" id="{E2BFFAE3-6CCE-FA34-F823-E5E193AAA54F}"/>
+                </a:ext>
+              </a:extLst>
+            </p:cNvPr>
+            <p:cNvSpPr/>
+            <p:nvPr/>
+          </p:nvSpPr>
+          <p:spPr>
+            <a:xfrm>
+              <a:off x="5292056" y="3585812"/>
+              <a:ext cx="4453856" cy="1078467"/>
+            </a:xfrm>
+            <a:prstGeom prst="rect">
+              <a:avLst/>
+            </a:prstGeom>
+            <a:solidFill>
+              <a:schemeClr val="bg1"/>
+            </a:solidFill>
+            <a:ln>
+              <a:solidFill>
+                <a:schemeClr val="bg1"/>
+              </a:solidFill>
+            </a:ln>
+          </p:spPr>
+          <p:style>
+            <a:lnRef idx="2">
+              <a:schemeClr val="accent1">
+                <a:shade val="15000"/>
+              </a:schemeClr>
+            </a:lnRef>
+            <a:fillRef idx="1">
+              <a:schemeClr val="accent1"/>
+            </a:fillRef>
+            <a:effectRef idx="0">
+              <a:schemeClr val="accent1"/>
+            </a:effectRef>
+            <a:fontRef idx="minor">
+              <a:schemeClr val="lt1"/>
+            </a:fontRef>
+          </p:style>
+          <p:txBody>
+            <a:bodyPr rtlCol="0" anchor="ctr"/>
+            <a:lstStyle/>
+            <a:p>
+              <a:pPr algn="ctr"/>
+              <a:endParaRPr lang="pt-BR"/>
+            </a:p>
+          </p:txBody>
+        </p:sp>
+      </p:grpSp>
+      <p:sp>
+        <p:nvSpPr>
+          <p:cNvPr id="16" name="Título 1">
+            <a:extLst>
+              <a:ext uri="{FF2B5EF4-FFF2-40B4-BE49-F238E27FC236}">
+                <a16:creationId xmlns:a16="http://schemas.microsoft.com/office/drawing/2014/main" id="{29EF4A97-8977-0649-CE9B-D87987B28823}"/>
+              </a:ext>
+            </a:extLst>
+          </p:cNvPr>
+          <p:cNvSpPr>
+            <a:spLocks noGrp="1"/>
+          </p:cNvSpPr>
+          <p:nvPr>
+            <p:ph type="title"/>
+          </p:nvPr>
+        </p:nvSpPr>
+        <p:spPr>
+          <a:xfrm>
+            <a:off x="305479" y="902711"/>
+            <a:ext cx="10515600" cy="1325563"/>
+          </a:xfrm>
+        </p:spPr>
+        <p:txBody>
+          <a:bodyPr>
+            <a:normAutofit/>
+          </a:bodyPr>
+          <a:lstStyle/>
+          <a:p>
+            <a:r>
+              <a:rPr lang="pt-BR" sz="2800" b="1" dirty="0">
+                <a:latin typeface="+mn-lt"/>
+              </a:rPr>
+              <a:t>Resultados</a:t>
+            </a:r>
+          </a:p>
+        </p:txBody>
+      </p:sp>
+      <p:pic>
+        <p:nvPicPr>
+          <p:cNvPr id="3" name="Imagem 2">
+            <a:extLst>
+              <a:ext uri="{FF2B5EF4-FFF2-40B4-BE49-F238E27FC236}">
+                <a16:creationId xmlns:a16="http://schemas.microsoft.com/office/drawing/2014/main" id="{2C717BB6-ECB5-EA1C-397D-9005A4D4B586}"/>
+              </a:ext>
+            </a:extLst>
+          </p:cNvPr>
+          <p:cNvPicPr>
+            <a:picLocks noChangeAspect="1"/>
+          </p:cNvPicPr>
+          <p:nvPr/>
+        </p:nvPicPr>
+        <p:blipFill>
+          <a:blip r:embed="rId4">
+            <a:extLst>
+              <a:ext uri="{28A0092B-C50C-407E-A947-70E740481C1C}">
+                <a14:useLocalDpi xmlns:a14="http://schemas.microsoft.com/office/drawing/2010/main" val="0"/>
+              </a:ext>
+            </a:extLst>
+          </a:blip>
+          <a:stretch>
+            <a:fillRect/>
+          </a:stretch>
+        </p:blipFill>
+        <p:spPr>
+          <a:xfrm>
+            <a:off x="2053516" y="1509372"/>
+            <a:ext cx="8968021" cy="5231346"/>
+          </a:xfrm>
+          <a:prstGeom prst="rect">
+            <a:avLst/>
+          </a:prstGeom>
+        </p:spPr>
+      </p:pic>
+    </p:spTree>
+    <p:extLst>
+      <p:ext uri="{BB962C8B-B14F-4D97-AF65-F5344CB8AC3E}">
+        <p14:creationId xmlns:p14="http://schemas.microsoft.com/office/powerpoint/2010/main" val="2996263216"/>
+      </p:ext>
+    </p:extLst>
+  </p:cSld>
+  <p:clrMapOvr>
+    <a:masterClrMapping/>
+  </p:clrMapOvr>
+</p:sld>
+</file>
+
+<file path=ppt/slides/slide6.xml><?xml version="1.0" encoding="utf-8"?>
+<p:sld xmlns:a="http://schemas.openxmlformats.org/drawingml/2006/main" xmlns:r="http://schemas.openxmlformats.org/officeDocument/2006/relationships" xmlns:p="http://schemas.openxmlformats.org/presentationml/2006/main">
+  <p:cSld>
+    <p:spTree>
+      <p:nvGrpSpPr>
+        <p:cNvPr id="1" name="">
+          <a:extLst>
+            <a:ext uri="{FF2B5EF4-FFF2-40B4-BE49-F238E27FC236}">
               <a16:creationId xmlns:a16="http://schemas.microsoft.com/office/drawing/2014/main" id="{D492F274-7D61-FEA2-F730-B29648AFA5A2}"/>
             </a:ext>
           </a:extLst>
@@ -9525,7 +9943,7 @@
 </p:sld>
 </file>
 
-<file path=ppt/slides/slide6.xml><?xml version="1.0" encoding="utf-8"?>
+<file path=ppt/slides/slide7.xml><?xml version="1.0" encoding="utf-8"?>
 <p:sld xmlns:a="http://schemas.openxmlformats.org/drawingml/2006/main" xmlns:r="http://schemas.openxmlformats.org/officeDocument/2006/relationships" xmlns:p="http://schemas.openxmlformats.org/presentationml/2006/main">
   <p:cSld>
     <p:spTree>
@@ -9791,7 +10209,7 @@
 </p:sld>
 </file>
 
-<file path=ppt/slides/slide7.xml><?xml version="1.0" encoding="utf-8"?>
+<file path=ppt/slides/slide8.xml><?xml version="1.0" encoding="utf-8"?>
 <p:sld xmlns:a="http://schemas.openxmlformats.org/drawingml/2006/main" xmlns:r="http://schemas.openxmlformats.org/officeDocument/2006/relationships" xmlns:p="http://schemas.openxmlformats.org/presentationml/2006/main">
   <p:cSld>
     <p:spTree>
@@ -10057,7 +10475,7 @@
 </p:sld>
 </file>
 
-<file path=ppt/slides/slide8.xml><?xml version="1.0" encoding="utf-8"?>
+<file path=ppt/slides/slide9.xml><?xml version="1.0" encoding="utf-8"?>
 <p:sld xmlns:a="http://schemas.openxmlformats.org/drawingml/2006/main" xmlns:r="http://schemas.openxmlformats.org/officeDocument/2006/relationships" xmlns:p="http://schemas.openxmlformats.org/presentationml/2006/main">
   <p:cSld>
     <p:spTree>
@@ -10623,540 +11041,6 @@
     <p:extLst>
       <p:ext uri="{BB962C8B-B14F-4D97-AF65-F5344CB8AC3E}">
         <p14:creationId xmlns:p14="http://schemas.microsoft.com/office/powerpoint/2010/main" val="3209490412"/>
-      </p:ext>
-    </p:extLst>
-  </p:cSld>
-  <p:clrMapOvr>
-    <a:masterClrMapping/>
-  </p:clrMapOvr>
-</p:sld>
-</file>
-
-<file path=ppt/slides/slide9.xml><?xml version="1.0" encoding="utf-8"?>
-<p:sld xmlns:a="http://schemas.openxmlformats.org/drawingml/2006/main" xmlns:r="http://schemas.openxmlformats.org/officeDocument/2006/relationships" xmlns:p="http://schemas.openxmlformats.org/presentationml/2006/main">
-  <p:cSld>
-    <p:spTree>
-      <p:nvGrpSpPr>
-        <p:cNvPr id="1" name="">
-          <a:extLst>
-            <a:ext uri="{FF2B5EF4-FFF2-40B4-BE49-F238E27FC236}">
-              <a16:creationId xmlns:a16="http://schemas.microsoft.com/office/drawing/2014/main" id="{E164B671-FC38-2847-0962-11B4314CAE5D}"/>
-            </a:ext>
-          </a:extLst>
-        </p:cNvPr>
-        <p:cNvGrpSpPr/>
-        <p:nvPr/>
-      </p:nvGrpSpPr>
-      <p:grpSpPr>
-        <a:xfrm>
-          <a:off x="0" y="0"/>
-          <a:ext cx="0" cy="0"/>
-          <a:chOff x="0" y="0"/>
-          <a:chExt cx="0" cy="0"/>
-        </a:xfrm>
-      </p:grpSpPr>
-      <p:pic>
-        <p:nvPicPr>
-          <p:cNvPr id="5" name="Imagem 4">
-            <a:extLst>
-              <a:ext uri="{FF2B5EF4-FFF2-40B4-BE49-F238E27FC236}">
-                <a16:creationId xmlns:a16="http://schemas.microsoft.com/office/drawing/2014/main" id="{14A210E9-96BE-6AEF-888F-BC27D770B970}"/>
-              </a:ext>
-            </a:extLst>
-          </p:cNvPr>
-          <p:cNvPicPr>
-            <a:picLocks noChangeAspect="1"/>
-          </p:cNvPicPr>
-          <p:nvPr/>
-        </p:nvPicPr>
-        <p:blipFill>
-          <a:blip r:embed="rId2"/>
-          <a:stretch>
-            <a:fillRect/>
-          </a:stretch>
-        </p:blipFill>
-        <p:spPr>
-          <a:xfrm>
-            <a:off x="0" y="0"/>
-            <a:ext cx="12192000" cy="1398060"/>
-          </a:xfrm>
-          <a:prstGeom prst="rect">
-            <a:avLst/>
-          </a:prstGeom>
-        </p:spPr>
-      </p:pic>
-      <p:grpSp>
-        <p:nvGrpSpPr>
-          <p:cNvPr id="10" name="Agrupar 9">
-            <a:extLst>
-              <a:ext uri="{FF2B5EF4-FFF2-40B4-BE49-F238E27FC236}">
-                <a16:creationId xmlns:a16="http://schemas.microsoft.com/office/drawing/2014/main" id="{6B17D0A5-FA6E-7612-F4EA-B08B6E431FA9}"/>
-              </a:ext>
-            </a:extLst>
-          </p:cNvPr>
-          <p:cNvGrpSpPr/>
-          <p:nvPr/>
-        </p:nvGrpSpPr>
-        <p:grpSpPr>
-          <a:xfrm>
-            <a:off x="4739781" y="3585812"/>
-            <a:ext cx="7452219" cy="3272188"/>
-            <a:chOff x="4739781" y="3585812"/>
-            <a:chExt cx="7452219" cy="3272188"/>
-          </a:xfrm>
-        </p:grpSpPr>
-        <p:pic>
-          <p:nvPicPr>
-            <p:cNvPr id="7" name="Imagem 6">
-              <a:extLst>
-                <a:ext uri="{FF2B5EF4-FFF2-40B4-BE49-F238E27FC236}">
-                  <a16:creationId xmlns:a16="http://schemas.microsoft.com/office/drawing/2014/main" id="{C0A576E9-D595-470C-A40E-2194D8494497}"/>
-                </a:ext>
-              </a:extLst>
-            </p:cNvPr>
-            <p:cNvPicPr>
-              <a:picLocks noChangeAspect="1"/>
-            </p:cNvPicPr>
-            <p:nvPr/>
-          </p:nvPicPr>
-          <p:blipFill>
-            <a:blip r:embed="rId3"/>
-            <a:stretch>
-              <a:fillRect/>
-            </a:stretch>
-          </p:blipFill>
-          <p:spPr>
-            <a:xfrm>
-              <a:off x="5492514" y="4013377"/>
-              <a:ext cx="6699486" cy="2844623"/>
-            </a:xfrm>
-            <a:prstGeom prst="rect">
-              <a:avLst/>
-            </a:prstGeom>
-            <a:effectLst>
-              <a:outerShdw blurRad="50800" dist="50800" dir="5400000" algn="ctr" rotWithShape="0">
-                <a:srgbClr val="000000"/>
-              </a:outerShdw>
-            </a:effectLst>
-          </p:spPr>
-        </p:pic>
-        <p:sp>
-          <p:nvSpPr>
-            <p:cNvPr id="8" name="Retângulo 7">
-              <a:extLst>
-                <a:ext uri="{FF2B5EF4-FFF2-40B4-BE49-F238E27FC236}">
-                  <a16:creationId xmlns:a16="http://schemas.microsoft.com/office/drawing/2014/main" id="{6330B5B5-14A9-566F-3454-C956FFC60E8C}"/>
-                </a:ext>
-              </a:extLst>
-            </p:cNvPr>
-            <p:cNvSpPr/>
-            <p:nvPr/>
-          </p:nvSpPr>
-          <p:spPr>
-            <a:xfrm>
-              <a:off x="4739781" y="4013377"/>
-              <a:ext cx="1104550" cy="2844623"/>
-            </a:xfrm>
-            <a:prstGeom prst="rect">
-              <a:avLst/>
-            </a:prstGeom>
-            <a:solidFill>
-              <a:schemeClr val="bg1"/>
-            </a:solidFill>
-            <a:ln>
-              <a:solidFill>
-                <a:schemeClr val="bg1"/>
-              </a:solidFill>
-            </a:ln>
-          </p:spPr>
-          <p:style>
-            <a:lnRef idx="2">
-              <a:schemeClr val="accent1">
-                <a:shade val="15000"/>
-              </a:schemeClr>
-            </a:lnRef>
-            <a:fillRef idx="1">
-              <a:schemeClr val="accent1"/>
-            </a:fillRef>
-            <a:effectRef idx="0">
-              <a:schemeClr val="accent1"/>
-            </a:effectRef>
-            <a:fontRef idx="minor">
-              <a:schemeClr val="lt1"/>
-            </a:fontRef>
-          </p:style>
-          <p:txBody>
-            <a:bodyPr rtlCol="0" anchor="ctr"/>
-            <a:lstStyle/>
-            <a:p>
-              <a:pPr algn="ctr"/>
-              <a:endParaRPr lang="pt-BR"/>
-            </a:p>
-          </p:txBody>
-        </p:sp>
-        <p:sp>
-          <p:nvSpPr>
-            <p:cNvPr id="9" name="Retângulo 8">
-              <a:extLst>
-                <a:ext uri="{FF2B5EF4-FFF2-40B4-BE49-F238E27FC236}">
-                  <a16:creationId xmlns:a16="http://schemas.microsoft.com/office/drawing/2014/main" id="{484C3208-5267-F20F-10D0-69E389B21B7E}"/>
-                </a:ext>
-              </a:extLst>
-            </p:cNvPr>
-            <p:cNvSpPr/>
-            <p:nvPr/>
-          </p:nvSpPr>
-          <p:spPr>
-            <a:xfrm>
-              <a:off x="5292056" y="3585812"/>
-              <a:ext cx="4453856" cy="1078467"/>
-            </a:xfrm>
-            <a:prstGeom prst="rect">
-              <a:avLst/>
-            </a:prstGeom>
-            <a:solidFill>
-              <a:schemeClr val="bg1"/>
-            </a:solidFill>
-            <a:ln>
-              <a:solidFill>
-                <a:schemeClr val="bg1"/>
-              </a:solidFill>
-            </a:ln>
-          </p:spPr>
-          <p:style>
-            <a:lnRef idx="2">
-              <a:schemeClr val="accent1">
-                <a:shade val="15000"/>
-              </a:schemeClr>
-            </a:lnRef>
-            <a:fillRef idx="1">
-              <a:schemeClr val="accent1"/>
-            </a:fillRef>
-            <a:effectRef idx="0">
-              <a:schemeClr val="accent1"/>
-            </a:effectRef>
-            <a:fontRef idx="minor">
-              <a:schemeClr val="lt1"/>
-            </a:fontRef>
-          </p:style>
-          <p:txBody>
-            <a:bodyPr rtlCol="0" anchor="ctr"/>
-            <a:lstStyle/>
-            <a:p>
-              <a:pPr algn="ctr"/>
-              <a:endParaRPr lang="pt-BR"/>
-            </a:p>
-          </p:txBody>
-        </p:sp>
-      </p:grpSp>
-      <p:sp>
-        <p:nvSpPr>
-          <p:cNvPr id="16" name="Título 1">
-            <a:extLst>
-              <a:ext uri="{FF2B5EF4-FFF2-40B4-BE49-F238E27FC236}">
-                <a16:creationId xmlns:a16="http://schemas.microsoft.com/office/drawing/2014/main" id="{3F1C265C-450B-E149-E6F1-8766C3132B27}"/>
-              </a:ext>
-            </a:extLst>
-          </p:cNvPr>
-          <p:cNvSpPr>
-            <a:spLocks noGrp="1"/>
-          </p:cNvSpPr>
-          <p:nvPr>
-            <p:ph type="title"/>
-          </p:nvPr>
-        </p:nvSpPr>
-        <p:spPr>
-          <a:xfrm>
-            <a:off x="474860" y="1162843"/>
-            <a:ext cx="10515600" cy="1325563"/>
-          </a:xfrm>
-        </p:spPr>
-        <p:txBody>
-          <a:bodyPr>
-            <a:normAutofit/>
-          </a:bodyPr>
-          <a:lstStyle/>
-          <a:p>
-            <a:r>
-              <a:rPr lang="pt-BR" sz="2800" b="1" dirty="0">
-                <a:latin typeface="+mn-lt"/>
-              </a:rPr>
-              <a:t>A Árvore BST e a Volatilidade Estrutural</a:t>
-            </a:r>
-          </a:p>
-        </p:txBody>
-      </p:sp>
-      <p:sp>
-        <p:nvSpPr>
-          <p:cNvPr id="13" name="Rectangle 1">
-            <a:extLst>
-              <a:ext uri="{FF2B5EF4-FFF2-40B4-BE49-F238E27FC236}">
-                <a16:creationId xmlns:a16="http://schemas.microsoft.com/office/drawing/2014/main" id="{379EF3F8-DAA6-B371-6726-DD0D059AD3EC}"/>
-              </a:ext>
-            </a:extLst>
-          </p:cNvPr>
-          <p:cNvSpPr>
-            <a:spLocks noGrp="1" noChangeArrowheads="1"/>
-          </p:cNvSpPr>
-          <p:nvPr>
-            <p:ph idx="1"/>
-          </p:nvPr>
-        </p:nvSpPr>
-        <p:spPr bwMode="auto">
-          <a:xfrm>
-            <a:off x="1075630" y="2382161"/>
-            <a:ext cx="10515600" cy="3262432"/>
-          </a:xfrm>
-          <a:prstGeom prst="rect">
-            <a:avLst/>
-          </a:prstGeom>
-          <a:noFill/>
-          <a:ln>
-            <a:noFill/>
-          </a:ln>
-          <a:effectLst/>
-          <a:extLst>
-            <a:ext uri="{909E8E84-426E-40DD-AFC4-6F175D3DCCD1}">
-              <a14:hiddenFill xmlns:a14="http://schemas.microsoft.com/office/drawing/2010/main">
-                <a:solidFill>
-                  <a:schemeClr val="accent1"/>
-                </a:solidFill>
-              </a14:hiddenFill>
-            </a:ext>
-            <a:ext uri="{91240B29-F687-4F45-9708-019B960494DF}">
-              <a14:hiddenLine xmlns:a14="http://schemas.microsoft.com/office/drawing/2010/main" w="9525">
-                <a:solidFill>
-                  <a:schemeClr val="tx1"/>
-                </a:solidFill>
-                <a:miter lim="800000"/>
-                <a:headEnd/>
-                <a:tailEnd/>
-              </a14:hiddenLine>
-            </a:ext>
-            <a:ext uri="{AF507438-7753-43E0-B8FC-AC1667EBCBE1}">
-              <a14:hiddenEffects xmlns:a14="http://schemas.microsoft.com/office/drawing/2010/main">
-                <a:effectLst>
-                  <a:outerShdw dist="35921" dir="2700000" algn="ctr" rotWithShape="0">
-                    <a:schemeClr val="bg2"/>
-                  </a:outerShdw>
-                </a:effectLst>
-              </a14:hiddenEffects>
-            </a:ext>
-          </a:extLst>
-        </p:spPr>
-        <p:txBody>
-          <a:bodyPr vert="horz" wrap="square" lIns="91440" tIns="45720" rIns="91440" bIns="45720" numCol="1" anchor="ctr" anchorCtr="0" compatLnSpc="1">
-            <a:prstTxWarp prst="textNoShape">
-              <a:avLst/>
-            </a:prstTxWarp>
-            <a:spAutoFit/>
-          </a:bodyPr>
-          <a:lstStyle/>
-          <a:p>
-            <a:pPr marL="0" indent="0" eaLnBrk="0" fontAlgn="base" hangingPunct="0">
-              <a:lnSpc>
-                <a:spcPct val="100000"/>
-              </a:lnSpc>
-              <a:spcBef>
-                <a:spcPct val="0"/>
-              </a:spcBef>
-              <a:spcAft>
-                <a:spcPct val="0"/>
-              </a:spcAft>
-              <a:buFontTx/>
-              <a:buChar char="•"/>
-            </a:pPr>
-            <a:r>
-              <a:rPr lang="pt-BR" altLang="pt-BR" sz="2400" b="1" dirty="0"/>
-              <a:t> Topologicamente vulnerável a entrada dos dados</a:t>
-            </a:r>
-          </a:p>
-          <a:p>
-            <a:pPr marL="0" indent="0" eaLnBrk="0" fontAlgn="base" hangingPunct="0">
-              <a:lnSpc>
-                <a:spcPct val="100000"/>
-              </a:lnSpc>
-              <a:spcBef>
-                <a:spcPct val="0"/>
-              </a:spcBef>
-              <a:spcAft>
-                <a:spcPct val="0"/>
-              </a:spcAft>
-              <a:buFontTx/>
-              <a:buChar char="•"/>
-            </a:pPr>
-            <a:endParaRPr lang="pt-BR" altLang="pt-BR" sz="2400" b="1" dirty="0"/>
-          </a:p>
-          <a:p>
-            <a:pPr marL="457200" lvl="1" indent="0" eaLnBrk="0" fontAlgn="base" hangingPunct="0">
-              <a:lnSpc>
-                <a:spcPct val="100000"/>
-              </a:lnSpc>
-              <a:spcBef>
-                <a:spcPct val="0"/>
-              </a:spcBef>
-              <a:spcAft>
-                <a:spcPct val="0"/>
-              </a:spcAft>
-              <a:buFontTx/>
-              <a:buChar char="•"/>
-            </a:pPr>
-            <a:r>
-              <a:rPr lang="pt-BR" altLang="pt-BR" sz="2000" b="1" dirty="0"/>
-              <a:t> Dados ordenados</a:t>
-            </a:r>
-          </a:p>
-          <a:p>
-            <a:pPr marL="914400" lvl="2" indent="0" eaLnBrk="0" fontAlgn="base" hangingPunct="0">
-              <a:lnSpc>
-                <a:spcPct val="100000"/>
-              </a:lnSpc>
-              <a:spcBef>
-                <a:spcPct val="0"/>
-              </a:spcBef>
-              <a:spcAft>
-                <a:spcPct val="0"/>
-              </a:spcAft>
-              <a:buFontTx/>
-              <a:buChar char="•"/>
-            </a:pPr>
-            <a:r>
-              <a:rPr lang="pt-BR" altLang="pt-BR" dirty="0"/>
-              <a:t> “Lista encadeada” - O(N)</a:t>
-            </a:r>
-          </a:p>
-          <a:p>
-            <a:pPr marL="457200" lvl="1" indent="0" eaLnBrk="0" fontAlgn="base" hangingPunct="0">
-              <a:lnSpc>
-                <a:spcPct val="100000"/>
-              </a:lnSpc>
-              <a:spcBef>
-                <a:spcPct val="0"/>
-              </a:spcBef>
-              <a:spcAft>
-                <a:spcPct val="0"/>
-              </a:spcAft>
-              <a:buFontTx/>
-              <a:buChar char="•"/>
-            </a:pPr>
-            <a:r>
-              <a:rPr lang="pt-BR" altLang="pt-BR" sz="2000" b="1" dirty="0"/>
-              <a:t> Dados aleatórios</a:t>
-            </a:r>
-          </a:p>
-          <a:p>
-            <a:pPr marL="914400" lvl="2" indent="0" eaLnBrk="0" fontAlgn="base" hangingPunct="0">
-              <a:lnSpc>
-                <a:spcPct val="100000"/>
-              </a:lnSpc>
-              <a:spcBef>
-                <a:spcPct val="0"/>
-              </a:spcBef>
-              <a:spcAft>
-                <a:spcPct val="0"/>
-              </a:spcAft>
-              <a:buFontTx/>
-              <a:buChar char="•"/>
-            </a:pPr>
-            <a:r>
-              <a:rPr lang="pt-BR" altLang="pt-BR" dirty="0"/>
-              <a:t> Árvore naturalmente balanceada</a:t>
-            </a:r>
-          </a:p>
-          <a:p>
-            <a:pPr marL="914400" lvl="2" indent="0" eaLnBrk="0" fontAlgn="base" hangingPunct="0">
-              <a:lnSpc>
-                <a:spcPct val="100000"/>
-              </a:lnSpc>
-              <a:spcBef>
-                <a:spcPct val="0"/>
-              </a:spcBef>
-              <a:spcAft>
-                <a:spcPct val="0"/>
-              </a:spcAft>
-              <a:buFontTx/>
-              <a:buChar char="•"/>
-            </a:pPr>
-            <a:r>
-              <a:rPr lang="pt-BR" altLang="pt-BR" dirty="0"/>
-              <a:t> Superou AVL no processamento sequencial</a:t>
-            </a:r>
-          </a:p>
-          <a:p>
-            <a:pPr marL="1371600" lvl="3" indent="0" eaLnBrk="0" fontAlgn="base" hangingPunct="0">
-              <a:lnSpc>
-                <a:spcPct val="100000"/>
-              </a:lnSpc>
-              <a:spcBef>
-                <a:spcPct val="0"/>
-              </a:spcBef>
-              <a:spcAft>
-                <a:spcPct val="0"/>
-              </a:spcAft>
-              <a:buFontTx/>
-              <a:buChar char="•"/>
-            </a:pPr>
-            <a:r>
-              <a:rPr lang="pt-BR" altLang="pt-BR" sz="2000" dirty="0"/>
-              <a:t>sem overhead de rotações automáticas</a:t>
-            </a:r>
-          </a:p>
-          <a:p>
-            <a:pPr marL="914400" lvl="2" indent="0" eaLnBrk="0" fontAlgn="base" hangingPunct="0">
-              <a:lnSpc>
-                <a:spcPct val="100000"/>
-              </a:lnSpc>
-              <a:spcBef>
-                <a:spcPct val="0"/>
-              </a:spcBef>
-              <a:spcAft>
-                <a:spcPct val="0"/>
-              </a:spcAft>
-              <a:buFontTx/>
-              <a:buChar char="•"/>
-            </a:pPr>
-            <a:endParaRPr kumimoji="0" lang="pt-BR" altLang="pt-BR" sz="1800" b="1" i="0" u="none" strike="noStrike" cap="none" normalizeH="0" baseline="0" dirty="0">
-              <a:ln>
-                <a:noFill/>
-              </a:ln>
-              <a:solidFill>
-                <a:schemeClr val="tx1"/>
-              </a:solidFill>
-              <a:effectLst/>
-              <a:latin typeface="Arial" panose="020B0604020202020204" pitchFamily="34" charset="0"/>
-            </a:endParaRPr>
-          </a:p>
-          <a:p>
-            <a:pPr marL="457200" lvl="1" indent="0" eaLnBrk="0" fontAlgn="base" hangingPunct="0">
-              <a:lnSpc>
-                <a:spcPct val="100000"/>
-              </a:lnSpc>
-              <a:spcBef>
-                <a:spcPct val="0"/>
-              </a:spcBef>
-              <a:spcAft>
-                <a:spcPct val="0"/>
-              </a:spcAft>
-              <a:buFontTx/>
-              <a:buAutoNum type="arabicPeriod"/>
-            </a:pPr>
-            <a:endParaRPr kumimoji="0" lang="pt-BR" altLang="pt-BR" sz="2000" b="0" i="0" u="none" strike="noStrike" cap="none" normalizeH="0" baseline="0" dirty="0">
-              <a:ln>
-                <a:noFill/>
-              </a:ln>
-              <a:solidFill>
-                <a:schemeClr val="tx1"/>
-              </a:solidFill>
-              <a:effectLst/>
-              <a:latin typeface="Google Sans Text"/>
-            </a:endParaRPr>
-          </a:p>
-        </p:txBody>
-      </p:sp>
-    </p:spTree>
-    <p:extLst>
-      <p:ext uri="{BB962C8B-B14F-4D97-AF65-F5344CB8AC3E}">
-        <p14:creationId xmlns:p14="http://schemas.microsoft.com/office/powerpoint/2010/main" val="3227322142"/>
       </p:ext>
     </p:extLst>
   </p:cSld>

</xml_diff>